<commit_message>
Expert system: situation assessment drives all outputs
Adds a structured situation questionnaire (margin trend, revenue
driver, concentration, capacity, cost program, competition, urgency)
and a scored opportunity library, so different situations produce
genuinely different findings, interview questions, and presentations.
Long pasted context becomes its own Analyst notes section instead of
breaking framing sentences. Demo numbers now require explicit consent
for named companies, and financials can be typed manually.

Co-Authored-By: Claude Fable 5 <noreply@anthropic.com>
</commit_message>
<xml_diff>
--- a/samples/financial_Presentation.pptx
+++ b/samples/financial_Presentation.pptx
@@ -1691,7 +1691,7 @@
                 <a:ea typeface="Georgia" pitchFamily="34" charset="-122"/>
                 <a:cs typeface="Georgia" pitchFamily="34" charset="-120"/>
               </a:rPr>
-              <a:t>Meridian Components Inc. presents 2 revenue synergies and 3 cost synergies; procurement scale and vendor consolidation offers the highest confidence value</a:t>
+              <a:t>Meridian Components Inc. presents 3 revenue synergies and 3 cost synergies; procurement scale and vendor consolidation offers the highest confidence value</a:t>
             </a:r>
             <a:endParaRPr lang="en-US" sz="1900" dirty="0"/>
           </a:p>
@@ -1949,110 +1949,10 @@
                 <a:ea typeface="Arial" pitchFamily="34" charset="-122"/>
                 <a:cs typeface="Arial" pitchFamily="34" charset="-120"/>
               </a:rPr>
-              <a:t>2. Geographic and channel expansion</a:t>
+              <a:t>2. Pricing harmonization</a:t>
             </a:r>
             <a:endParaRPr lang="en-US" sz="1300" dirty="0"/>
           </a:p>
-        </p:txBody>
-      </p:sp>
-      <p:sp>
-        <p:nvSpPr>
-          <p:cNvPr id="12" name="Text 10"/>
-          <p:cNvSpPr/>
-          <p:nvPr/>
-        </p:nvSpPr>
-        <p:spPr>
-          <a:xfrm>
-            <a:off x="411480" y="4892040"/>
-            <a:ext cx="5577840" cy="274320"/>
-          </a:xfrm>
-          <a:prstGeom prst="rect">
-            <a:avLst/>
-          </a:prstGeom>
-          <a:noFill/>
-          <a:ln/>
-        </p:spPr>
-        <p:txBody>
-          <a:bodyPr wrap="square" rtlCol="0" anchor="ctr"/>
-          <a:lstStyle/>
-          <a:p>
-            <a:pPr indent="0" marL="0">
-              <a:buNone/>
-            </a:pPr>
-            <a:r>
-              <a:rPr lang="en-US" sz="1000" i="1" dirty="0">
-                <a:solidFill>
-                  <a:srgbClr val="63666A"/>
-                </a:solidFill>
-                <a:latin typeface="Arial" pitchFamily="34" charset="0"/>
-                <a:ea typeface="Arial" pitchFamily="34" charset="-122"/>
-                <a:cs typeface="Arial" pitchFamily="34" charset="-120"/>
-              </a:rPr>
-              <a:t>Expanded on slide 2</a:t>
-            </a:r>
-            <a:endParaRPr lang="en-US" sz="1000" dirty="0"/>
-          </a:p>
-        </p:txBody>
-      </p:sp>
-      <p:sp>
-        <p:nvSpPr>
-          <p:cNvPr id="13" name="Text 11"/>
-          <p:cNvSpPr/>
-          <p:nvPr/>
-        </p:nvSpPr>
-        <p:spPr>
-          <a:xfrm>
-            <a:off x="6172200" y="2057400"/>
-            <a:ext cx="5577840" cy="320040"/>
-          </a:xfrm>
-          <a:prstGeom prst="rect">
-            <a:avLst/>
-          </a:prstGeom>
-          <a:noFill/>
-          <a:ln/>
-        </p:spPr>
-        <p:txBody>
-          <a:bodyPr wrap="square" rtlCol="0" anchor="ctr"/>
-          <a:lstStyle/>
-          <a:p>
-            <a:pPr indent="0" marL="0">
-              <a:buNone/>
-            </a:pPr>
-            <a:r>
-              <a:rPr lang="en-US" sz="1200" b="1" spc="100" kern="0" dirty="0">
-                <a:solidFill>
-                  <a:srgbClr val="1F4CFF"/>
-                </a:solidFill>
-                <a:latin typeface="Arial" pitchFamily="34" charset="0"/>
-                <a:ea typeface="Arial" pitchFamily="34" charset="-122"/>
-                <a:cs typeface="Arial" pitchFamily="34" charset="-120"/>
-              </a:rPr>
-              <a:t>2. COST SYNERGIES</a:t>
-            </a:r>
-            <a:endParaRPr lang="en-US" sz="1200" dirty="0"/>
-          </a:p>
-        </p:txBody>
-      </p:sp>
-      <p:sp>
-        <p:nvSpPr>
-          <p:cNvPr id="14" name="Text 12"/>
-          <p:cNvSpPr/>
-          <p:nvPr/>
-        </p:nvSpPr>
-        <p:spPr>
-          <a:xfrm>
-            <a:off x="6172200" y="2423160"/>
-            <a:ext cx="5577840" cy="2194560"/>
-          </a:xfrm>
-          <a:prstGeom prst="rect">
-            <a:avLst/>
-          </a:prstGeom>
-          <a:noFill/>
-          <a:ln/>
-        </p:spPr>
-        <p:txBody>
-          <a:bodyPr wrap="square" rtlCol="0" anchor="t"/>
-          <a:lstStyle/>
           <a:p>
             <a:pPr indent="0" marL="0">
               <a:lnSpc>
@@ -2069,10 +1969,110 @@
                 <a:ea typeface="Arial" pitchFamily="34" charset="-122"/>
                 <a:cs typeface="Arial" pitchFamily="34" charset="-120"/>
               </a:rPr>
-              <a:t>3. Procurement scale and vendor consolidation</a:t>
+              <a:t>3. Key account retention program</a:t>
             </a:r>
             <a:endParaRPr lang="en-US" sz="1300" dirty="0"/>
           </a:p>
+        </p:txBody>
+      </p:sp>
+      <p:sp>
+        <p:nvSpPr>
+          <p:cNvPr id="12" name="Text 10"/>
+          <p:cNvSpPr/>
+          <p:nvPr/>
+        </p:nvSpPr>
+        <p:spPr>
+          <a:xfrm>
+            <a:off x="411480" y="4892040"/>
+            <a:ext cx="5577840" cy="274320"/>
+          </a:xfrm>
+          <a:prstGeom prst="rect">
+            <a:avLst/>
+          </a:prstGeom>
+          <a:noFill/>
+          <a:ln/>
+        </p:spPr>
+        <p:txBody>
+          <a:bodyPr wrap="square" rtlCol="0" anchor="ctr"/>
+          <a:lstStyle/>
+          <a:p>
+            <a:pPr indent="0" marL="0">
+              <a:buNone/>
+            </a:pPr>
+            <a:r>
+              <a:rPr lang="en-US" sz="1000" i="1" dirty="0">
+                <a:solidFill>
+                  <a:srgbClr val="63666A"/>
+                </a:solidFill>
+                <a:latin typeface="Arial" pitchFamily="34" charset="0"/>
+                <a:ea typeface="Arial" pitchFamily="34" charset="-122"/>
+                <a:cs typeface="Arial" pitchFamily="34" charset="-120"/>
+              </a:rPr>
+              <a:t>Expanded on slide 2</a:t>
+            </a:r>
+            <a:endParaRPr lang="en-US" sz="1000" dirty="0"/>
+          </a:p>
+        </p:txBody>
+      </p:sp>
+      <p:sp>
+        <p:nvSpPr>
+          <p:cNvPr id="13" name="Text 11"/>
+          <p:cNvSpPr/>
+          <p:nvPr/>
+        </p:nvSpPr>
+        <p:spPr>
+          <a:xfrm>
+            <a:off x="6172200" y="2057400"/>
+            <a:ext cx="5577840" cy="320040"/>
+          </a:xfrm>
+          <a:prstGeom prst="rect">
+            <a:avLst/>
+          </a:prstGeom>
+          <a:noFill/>
+          <a:ln/>
+        </p:spPr>
+        <p:txBody>
+          <a:bodyPr wrap="square" rtlCol="0" anchor="ctr"/>
+          <a:lstStyle/>
+          <a:p>
+            <a:pPr indent="0" marL="0">
+              <a:buNone/>
+            </a:pPr>
+            <a:r>
+              <a:rPr lang="en-US" sz="1200" b="1" spc="100" kern="0" dirty="0">
+                <a:solidFill>
+                  <a:srgbClr val="1F4CFF"/>
+                </a:solidFill>
+                <a:latin typeface="Arial" pitchFamily="34" charset="0"/>
+                <a:ea typeface="Arial" pitchFamily="34" charset="-122"/>
+                <a:cs typeface="Arial" pitchFamily="34" charset="-120"/>
+              </a:rPr>
+              <a:t>2. COST SYNERGIES</a:t>
+            </a:r>
+            <a:endParaRPr lang="en-US" sz="1200" dirty="0"/>
+          </a:p>
+        </p:txBody>
+      </p:sp>
+      <p:sp>
+        <p:nvSpPr>
+          <p:cNvPr id="14" name="Text 12"/>
+          <p:cNvSpPr/>
+          <p:nvPr/>
+        </p:nvSpPr>
+        <p:spPr>
+          <a:xfrm>
+            <a:off x="6172200" y="2423160"/>
+            <a:ext cx="5577840" cy="2194560"/>
+          </a:xfrm>
+          <a:prstGeom prst="rect">
+            <a:avLst/>
+          </a:prstGeom>
+          <a:noFill/>
+          <a:ln/>
+        </p:spPr>
+        <p:txBody>
+          <a:bodyPr wrap="square" rtlCol="0" anchor="t"/>
+          <a:lstStyle/>
           <a:p>
             <a:pPr indent="0" marL="0">
               <a:lnSpc>
@@ -2089,7 +2089,7 @@
                 <a:ea typeface="Arial" pitchFamily="34" charset="-122"/>
                 <a:cs typeface="Arial" pitchFamily="34" charset="-120"/>
               </a:rPr>
-              <a:t>4. Overlapping G&amp;A rationalization</a:t>
+              <a:t>4. Procurement scale and vendor consolidation</a:t>
             </a:r>
             <a:endParaRPr lang="en-US" sz="1300" dirty="0"/>
           </a:p>
@@ -2109,7 +2109,27 @@
                 <a:ea typeface="Arial" pitchFamily="34" charset="-122"/>
                 <a:cs typeface="Arial" pitchFamily="34" charset="-120"/>
               </a:rPr>
-              <a:t>5. Facility and footprint optimization</a:t>
+              <a:t>5. Margin improvement to peer levels</a:t>
+            </a:r>
+            <a:endParaRPr lang="en-US" sz="1300" dirty="0"/>
+          </a:p>
+          <a:p>
+            <a:pPr indent="0" marL="0">
+              <a:lnSpc>
+                <a:spcPts val="2600"/>
+              </a:lnSpc>
+              <a:buNone/>
+            </a:pPr>
+            <a:r>
+              <a:rPr lang="en-US" sz="1300" dirty="0">
+                <a:solidFill>
+                  <a:srgbClr val="0A1F2E"/>
+                </a:solidFill>
+                <a:latin typeface="Arial" pitchFamily="34" charset="0"/>
+                <a:ea typeface="Arial" pitchFamily="34" charset="-122"/>
+                <a:cs typeface="Arial" pitchFamily="34" charset="-120"/>
+              </a:rPr>
+              <a:t>6. Overlapping G&amp;A rationalization</a:t>
             </a:r>
             <a:endParaRPr lang="en-US" sz="1300" dirty="0"/>
           </a:p>
@@ -2338,7 +2358,7 @@
                 <a:ea typeface="Georgia" pitchFamily="34" charset="-122"/>
                 <a:cs typeface="Georgia" pitchFamily="34" charset="-120"/>
               </a:rPr>
-              <a:t>Revenue synergies center on cross selling into the combined customer base and widening the addressable footprint</a:t>
+              <a:t>Revenue synergies are ranked by fit with this transaction</a:t>
             </a:r>
             <a:endParaRPr lang="en-US" sz="1900" dirty="0"/>
           </a:p>
@@ -2592,7 +2612,7 @@
                 <a:ea typeface="Arial" pitchFamily="34" charset="-122"/>
                 <a:cs typeface="Arial" pitchFamily="34" charset="-120"/>
               </a:rPr>
-              <a:t>Meridian Components Inc.'s customers can be offered the acquirer's adjacent products, and vice versa.</a:t>
+              <a:t>Customers of each business can be offered the other's adjacent products.</a:t>
             </a:r>
             <a:endParaRPr lang="en-US" sz="1250" dirty="0"/>
           </a:p>
@@ -2672,7 +2692,7 @@
                 <a:ea typeface="Arial" pitchFamily="34" charset="-122"/>
                 <a:cs typeface="Arial" pitchFamily="34" charset="-120"/>
               </a:rPr>
-              <a:t>Geographic and channel expansion</a:t>
+              <a:t>Pricing harmonization</a:t>
             </a:r>
             <a:pPr indent="0" marL="0">
               <a:buNone/>
@@ -2686,7 +2706,7 @@
                 <a:ea typeface="Arial" pitchFamily="34" charset="-122"/>
                 <a:cs typeface="Arial" pitchFamily="34" charset="-120"/>
               </a:rPr>
-              <a:t>   Impact: Medium  |  Ease: Medium</a:t>
+              <a:t>   Impact: Medium  |  Ease: High</a:t>
             </a:r>
             <a:endParaRPr lang="en-US" sz="1500" dirty="0"/>
           </a:p>
@@ -2728,7 +2748,143 @@
                 <a:ea typeface="Arial" pitchFamily="34" charset="-122"/>
                 <a:cs typeface="Arial" pitchFamily="34" charset="-120"/>
               </a:rPr>
-              <a:t>The combined footprint opens regions and channels neither business serves alone.</a:t>
+              <a:t>Aligning price levels and discount discipline across the combined book lifts realized price.</a:t>
+            </a:r>
+            <a:endParaRPr lang="en-US" sz="1250" dirty="0"/>
+          </a:p>
+        </p:txBody>
+      </p:sp>
+      <p:sp>
+        <p:nvSpPr>
+          <p:cNvPr id="15" name="Text 13"/>
+          <p:cNvSpPr/>
+          <p:nvPr/>
+        </p:nvSpPr>
+        <p:spPr>
+          <a:xfrm>
+            <a:off x="411480" y="4242816"/>
+            <a:ext cx="384048" cy="384048"/>
+          </a:xfrm>
+          <a:prstGeom prst="ellipse">
+            <a:avLst/>
+          </a:prstGeom>
+          <a:solidFill>
+            <a:srgbClr val="00A0B0"/>
+          </a:solidFill>
+          <a:ln/>
+        </p:spPr>
+        <p:txBody>
+          <a:bodyPr wrap="square" rtlCol="0" anchor="ctr"/>
+          <a:lstStyle/>
+          <a:p>
+            <a:pPr algn="ctr" indent="0" marL="0">
+              <a:buNone/>
+            </a:pPr>
+            <a:r>
+              <a:rPr lang="en-US" sz="1300" b="1" dirty="0">
+                <a:solidFill>
+                  <a:srgbClr val="FFFFFF"/>
+                </a:solidFill>
+                <a:latin typeface="Arial" pitchFamily="34" charset="0"/>
+                <a:ea typeface="Arial" pitchFamily="34" charset="-122"/>
+                <a:cs typeface="Arial" pitchFamily="34" charset="-120"/>
+              </a:rPr>
+              <a:t>3</a:t>
+            </a:r>
+            <a:endParaRPr lang="en-US" sz="1300" dirty="0"/>
+          </a:p>
+        </p:txBody>
+      </p:sp>
+      <p:sp>
+        <p:nvSpPr>
+          <p:cNvPr id="16" name="Text 14"/>
+          <p:cNvSpPr/>
+          <p:nvPr/>
+        </p:nvSpPr>
+        <p:spPr>
+          <a:xfrm>
+            <a:off x="960120" y="4206240"/>
+            <a:ext cx="10698480" cy="384048"/>
+          </a:xfrm>
+          <a:prstGeom prst="rect">
+            <a:avLst/>
+          </a:prstGeom>
+          <a:noFill/>
+          <a:ln/>
+        </p:spPr>
+        <p:txBody>
+          <a:bodyPr wrap="square" rtlCol="0" anchor="ctr"/>
+          <a:lstStyle/>
+          <a:p>
+            <a:pPr indent="0" marL="0">
+              <a:buNone/>
+            </a:pPr>
+            <a:r>
+              <a:rPr lang="en-US" sz="1500" b="1" dirty="0">
+                <a:solidFill>
+                  <a:srgbClr val="0A1F2E"/>
+                </a:solidFill>
+                <a:latin typeface="Arial" pitchFamily="34" charset="0"/>
+                <a:ea typeface="Arial" pitchFamily="34" charset="-122"/>
+                <a:cs typeface="Arial" pitchFamily="34" charset="-120"/>
+              </a:rPr>
+              <a:t>Key account retention program</a:t>
+            </a:r>
+            <a:pPr indent="0" marL="0">
+              <a:buNone/>
+            </a:pPr>
+            <a:r>
+              <a:rPr lang="en-US" sz="1050" dirty="0">
+                <a:solidFill>
+                  <a:srgbClr val="63666A"/>
+                </a:solidFill>
+                <a:latin typeface="Arial" pitchFamily="34" charset="0"/>
+                <a:ea typeface="Arial" pitchFamily="34" charset="-122"/>
+                <a:cs typeface="Arial" pitchFamily="34" charset="-120"/>
+              </a:rPr>
+              <a:t>   Impact: High  |  Ease: Medium</a:t>
+            </a:r>
+            <a:endParaRPr lang="en-US" sz="1500" dirty="0"/>
+          </a:p>
+        </p:txBody>
+      </p:sp>
+      <p:sp>
+        <p:nvSpPr>
+          <p:cNvPr id="17" name="Text 15"/>
+          <p:cNvSpPr/>
+          <p:nvPr/>
+        </p:nvSpPr>
+        <p:spPr>
+          <a:xfrm>
+            <a:off x="960120" y="4608576"/>
+            <a:ext cx="10698480" cy="868680"/>
+          </a:xfrm>
+          <a:prstGeom prst="rect">
+            <a:avLst/>
+          </a:prstGeom>
+          <a:noFill/>
+          <a:ln/>
+        </p:spPr>
+        <p:txBody>
+          <a:bodyPr wrap="square" rtlCol="0" anchor="t"/>
+          <a:lstStyle/>
+          <a:p>
+            <a:pPr indent="0" marL="0">
+              <a:lnSpc>
+                <a:spcPts val="1800"/>
+              </a:lnSpc>
+              <a:buNone/>
+            </a:pPr>
+            <a:r>
+              <a:rPr lang="en-US" sz="1250" dirty="0">
+                <a:solidFill>
+                  <a:srgbClr val="404850"/>
+                </a:solidFill>
+                <a:latin typeface="Arial" pitchFamily="34" charset="0"/>
+                <a:ea typeface="Arial" pitchFamily="34" charset="-122"/>
+                <a:cs typeface="Arial" pitchFamily="34" charset="-120"/>
+              </a:rPr>
+              <a:t>Concentrated revenue makes protecting the largest relationships through close the first revenue priority.</a:t>
             </a:r>
             <a:endParaRPr lang="en-US" sz="1250" dirty="0"/>
           </a:p>
@@ -2918,7 +3074,7 @@
                 <a:ea typeface="Georgia" pitchFamily="34" charset="-122"/>
                 <a:cs typeface="Georgia" pitchFamily="34" charset="-120"/>
               </a:rPr>
-              <a:t>Procurement scale and overlapping G&amp;A anchor the cost case, with capture feasible inside 24 months</a:t>
+              <a:t>Cost synergies anchor the value case and are within management's control</a:t>
             </a:r>
             <a:endParaRPr lang="en-US" sz="1900" dirty="0"/>
           </a:p>
@@ -2997,7 +3153,7 @@
                 <a:ea typeface="Arial" pitchFamily="34" charset="-122"/>
                 <a:cs typeface="Arial" pitchFamily="34" charset="-120"/>
               </a:rPr>
-              <a:t>Cost synergies should anchor the value case; they are within management's direct control</a:t>
+              <a:t>Cost synergies should anchor the value case; sequence procurement first</a:t>
             </a:r>
             <a:endParaRPr lang="en-US" sz="1250" dirty="0"/>
           </a:p>
@@ -3077,7 +3233,7 @@
                 <a:ea typeface="Arial" pitchFamily="34" charset="-122"/>
                 <a:cs typeface="Arial" pitchFamily="34" charset="-120"/>
               </a:rPr>
-              <a:t>3</a:t>
+              <a:t>4</a:t>
             </a:r>
             <a:endParaRPr lang="en-US" sz="1300" dirty="0"/>
           </a:p>
@@ -3213,7 +3369,7 @@
                 <a:ea typeface="Arial" pitchFamily="34" charset="-122"/>
                 <a:cs typeface="Arial" pitchFamily="34" charset="-120"/>
               </a:rPr>
-              <a:t>4</a:t>
+              <a:t>5</a:t>
             </a:r>
             <a:endParaRPr lang="en-US" sz="1300" dirty="0"/>
           </a:p>
@@ -3252,7 +3408,7 @@
                 <a:ea typeface="Arial" pitchFamily="34" charset="-122"/>
                 <a:cs typeface="Arial" pitchFamily="34" charset="-120"/>
               </a:rPr>
-              <a:t>Overlapping G&amp;A rationalization</a:t>
+              <a:t>Margin improvement to peer levels</a:t>
             </a:r>
             <a:pPr indent="0" marL="0">
               <a:buNone/>
@@ -3266,7 +3422,7 @@
                 <a:ea typeface="Arial" pitchFamily="34" charset="-122"/>
                 <a:cs typeface="Arial" pitchFamily="34" charset="-120"/>
               </a:rPr>
-              <a:t>   Impact: Medium  |  Ease: Medium</a:t>
+              <a:t>   Impact: High  |  Ease: Medium</a:t>
             </a:r>
             <a:endParaRPr lang="en-US" sz="1500" dirty="0"/>
           </a:p>
@@ -3308,7 +3464,7 @@
                 <a:ea typeface="Arial" pitchFamily="34" charset="-122"/>
                 <a:cs typeface="Arial" pitchFamily="34" charset="-120"/>
               </a:rPr>
-              <a:t>Duplicated back office functions (finance, HR, IT) can be consolidated over 12 to 24 months.</a:t>
+              <a:t>Profitability trails typical sector levels, an addressable opportunity independent of the deal.</a:t>
             </a:r>
             <a:endParaRPr lang="en-US" sz="1250" dirty="0"/>
           </a:p>
@@ -3349,7 +3505,7 @@
                 <a:ea typeface="Arial" pitchFamily="34" charset="-122"/>
                 <a:cs typeface="Arial" pitchFamily="34" charset="-120"/>
               </a:rPr>
-              <a:t>5</a:t>
+              <a:t>6</a:t>
             </a:r>
             <a:endParaRPr lang="en-US" sz="1300" dirty="0"/>
           </a:p>
@@ -3388,7 +3544,7 @@
                 <a:ea typeface="Arial" pitchFamily="34" charset="-122"/>
                 <a:cs typeface="Arial" pitchFamily="34" charset="-120"/>
               </a:rPr>
-              <a:t>Facility and footprint optimization</a:t>
+              <a:t>Overlapping G&amp;A rationalization</a:t>
             </a:r>
             <a:pPr indent="0" marL="0">
               <a:buNone/>
@@ -3402,7 +3558,7 @@
                 <a:ea typeface="Arial" pitchFamily="34" charset="-122"/>
                 <a:cs typeface="Arial" pitchFamily="34" charset="-120"/>
               </a:rPr>
-              <a:t>   Impact: Medium  |  Ease: Low</a:t>
+              <a:t>   Impact: Medium  |  Ease: Medium</a:t>
             </a:r>
             <a:endParaRPr lang="en-US" sz="1500" dirty="0"/>
           </a:p>
@@ -3444,7 +3600,7 @@
                 <a:ea typeface="Arial" pitchFamily="34" charset="-122"/>
                 <a:cs typeface="Arial" pitchFamily="34" charset="-120"/>
               </a:rPr>
-              <a:t>Locating operations together reduces lease and logistics costs where geographies overlap.</a:t>
+              <a:t>Duplicated back office functions can be consolidated over 12 to 24 months.</a:t>
             </a:r>
             <a:endParaRPr lang="en-US" sz="1250" dirty="0"/>
           </a:p>
@@ -3936,7 +4092,7 @@
         </p:nvSpPr>
         <p:spPr>
           <a:xfrm>
-            <a:off x="4014216" y="3282696"/>
+            <a:off x="5934456" y="3282696"/>
             <a:ext cx="384048" cy="384048"/>
           </a:xfrm>
           <a:prstGeom prst="ellipse">
@@ -3977,6 +4133,47 @@
         </p:nvSpPr>
         <p:spPr>
           <a:xfrm>
+            <a:off x="4517136" y="2048256"/>
+            <a:ext cx="384048" cy="384048"/>
+          </a:xfrm>
+          <a:prstGeom prst="ellipse">
+            <a:avLst/>
+          </a:prstGeom>
+          <a:solidFill>
+            <a:srgbClr val="00A0B0"/>
+          </a:solidFill>
+          <a:ln/>
+        </p:spPr>
+        <p:txBody>
+          <a:bodyPr wrap="square" rtlCol="0" anchor="ctr"/>
+          <a:lstStyle/>
+          <a:p>
+            <a:pPr algn="ctr" indent="0" marL="0">
+              <a:buNone/>
+            </a:pPr>
+            <a:r>
+              <a:rPr lang="en-US" sz="1200" b="1" dirty="0">
+                <a:solidFill>
+                  <a:srgbClr val="FFFFFF"/>
+                </a:solidFill>
+                <a:latin typeface="Arial" pitchFamily="34" charset="0"/>
+                <a:ea typeface="Arial" pitchFamily="34" charset="-122"/>
+                <a:cs typeface="Arial" pitchFamily="34" charset="-120"/>
+              </a:rPr>
+              <a:t>3</a:t>
+            </a:r>
+            <a:endParaRPr lang="en-US" sz="1200" dirty="0"/>
+          </a:p>
+        </p:txBody>
+      </p:sp>
+      <p:sp>
+        <p:nvSpPr>
+          <p:cNvPr id="16" name="Text 14"/>
+          <p:cNvSpPr/>
+          <p:nvPr/>
+        </p:nvSpPr>
+        <p:spPr>
+          <a:xfrm>
             <a:off x="5934456" y="2048256"/>
             <a:ext cx="384048" cy="384048"/>
           </a:xfrm>
@@ -4004,7 +4201,7 @@
                 <a:ea typeface="Arial" pitchFamily="34" charset="-122"/>
                 <a:cs typeface="Arial" pitchFamily="34" charset="-120"/>
               </a:rPr>
-              <a:t>3</a:t>
+              <a:t>4</a:t>
             </a:r>
             <a:endParaRPr lang="en-US" sz="1200" dirty="0"/>
           </a:p>
@@ -4012,13 +4209,13 @@
       </p:sp>
       <p:sp>
         <p:nvSpPr>
-          <p:cNvPr id="16" name="Text 14"/>
-          <p:cNvSpPr/>
-          <p:nvPr/>
-        </p:nvSpPr>
-        <p:spPr>
-          <a:xfrm>
-            <a:off x="4517136" y="3282696"/>
+          <p:cNvPr id="17" name="Text 15"/>
+          <p:cNvSpPr/>
+          <p:nvPr/>
+        </p:nvSpPr>
+        <p:spPr>
+          <a:xfrm>
+            <a:off x="5020056" y="2048256"/>
             <a:ext cx="384048" cy="384048"/>
           </a:xfrm>
           <a:prstGeom prst="ellipse">
@@ -4045,7 +4242,7 @@
                 <a:ea typeface="Arial" pitchFamily="34" charset="-122"/>
                 <a:cs typeface="Arial" pitchFamily="34" charset="-120"/>
               </a:rPr>
-              <a:t>4</a:t>
+              <a:t>5</a:t>
             </a:r>
             <a:endParaRPr lang="en-US" sz="1200" dirty="0"/>
           </a:p>
@@ -4053,13 +4250,13 @@
       </p:sp>
       <p:sp>
         <p:nvSpPr>
-          <p:cNvPr id="17" name="Text 15"/>
-          <p:cNvSpPr/>
-          <p:nvPr/>
-        </p:nvSpPr>
-        <p:spPr>
-          <a:xfrm>
-            <a:off x="2093976" y="3282696"/>
+          <p:cNvPr id="18" name="Text 16"/>
+          <p:cNvSpPr/>
+          <p:nvPr/>
+        </p:nvSpPr>
+        <p:spPr>
+          <a:xfrm>
+            <a:off x="4014216" y="3282696"/>
             <a:ext cx="384048" cy="384048"/>
           </a:xfrm>
           <a:prstGeom prst="ellipse">
@@ -4086,7 +4283,7 @@
                 <a:ea typeface="Arial" pitchFamily="34" charset="-122"/>
                 <a:cs typeface="Arial" pitchFamily="34" charset="-120"/>
               </a:rPr>
-              <a:t>5</a:t>
+              <a:t>6</a:t>
             </a:r>
             <a:endParaRPr lang="en-US" sz="1200" dirty="0"/>
           </a:p>
@@ -4094,7 +4291,7 @@
       </p:sp>
       <p:sp>
         <p:nvSpPr>
-          <p:cNvPr id="18" name="Text 16"/>
+          <p:cNvPr id="19" name="Text 17"/>
           <p:cNvSpPr/>
           <p:nvPr/>
         </p:nvSpPr>
@@ -4133,7 +4330,7 @@
       </p:sp>
       <p:sp>
         <p:nvSpPr>
-          <p:cNvPr id="19" name="Text 17"/>
+          <p:cNvPr id="20" name="Text 18"/>
           <p:cNvSpPr/>
           <p:nvPr/>
         </p:nvSpPr>
@@ -4187,7 +4384,7 @@
                 <a:ea typeface="Arial" pitchFamily="34" charset="-122"/>
                 <a:cs typeface="Arial" pitchFamily="34" charset="-120"/>
               </a:rPr>
-              <a:t>2. Geographic and channel expansion</a:t>
+              <a:t>2. Pricing harmonization</a:t>
             </a:r>
             <a:endParaRPr lang="en-US" sz="1100" dirty="0"/>
           </a:p>
@@ -4207,7 +4404,7 @@
                 <a:ea typeface="Arial" pitchFamily="34" charset="-122"/>
                 <a:cs typeface="Arial" pitchFamily="34" charset="-120"/>
               </a:rPr>
-              <a:t>3. Procurement scale and vendor consolidation</a:t>
+              <a:t>3. Key account retention program</a:t>
             </a:r>
             <a:endParaRPr lang="en-US" sz="1100" dirty="0"/>
           </a:p>
@@ -4227,7 +4424,7 @@
                 <a:ea typeface="Arial" pitchFamily="34" charset="-122"/>
                 <a:cs typeface="Arial" pitchFamily="34" charset="-120"/>
               </a:rPr>
-              <a:t>4. Overlapping G&amp;A rationalization</a:t>
+              <a:t>4. Procurement scale and vendor consolidation</a:t>
             </a:r>
             <a:endParaRPr lang="en-US" sz="1100" dirty="0"/>
           </a:p>
@@ -4247,15 +4444,35 @@
                 <a:ea typeface="Arial" pitchFamily="34" charset="-122"/>
                 <a:cs typeface="Arial" pitchFamily="34" charset="-120"/>
               </a:rPr>
-              <a:t>5. Facility and footprint optimization</a:t>
+              <a:t>5. Margin improvement to peer levels</a:t>
             </a:r>
             <a:endParaRPr lang="en-US" sz="1100" dirty="0"/>
           </a:p>
-        </p:txBody>
-      </p:sp>
-      <p:sp>
-        <p:nvSpPr>
-          <p:cNvPr id="20" name="Text 18"/>
+          <a:p>
+            <a:pPr indent="0" marL="0">
+              <a:lnSpc>
+                <a:spcPts val="2000"/>
+              </a:lnSpc>
+              <a:buNone/>
+            </a:pPr>
+            <a:r>
+              <a:rPr lang="en-US" sz="1100" dirty="0">
+                <a:solidFill>
+                  <a:srgbClr val="404850"/>
+                </a:solidFill>
+                <a:latin typeface="Arial" pitchFamily="34" charset="0"/>
+                <a:ea typeface="Arial" pitchFamily="34" charset="-122"/>
+                <a:cs typeface="Arial" pitchFamily="34" charset="-120"/>
+              </a:rPr>
+              <a:t>6. Overlapping G&amp;A rationalization</a:t>
+            </a:r>
+            <a:endParaRPr lang="en-US" sz="1100" dirty="0"/>
+          </a:p>
+        </p:txBody>
+      </p:sp>
+      <p:sp>
+        <p:nvSpPr>
+          <p:cNvPr id="21" name="Text 19"/>
           <p:cNvSpPr/>
           <p:nvPr/>
         </p:nvSpPr>

</xml_diff>

<commit_message>
Fix doubled framing sentences and deck text overflow
Contexts that already read as framing sentences are used as the frame
instead of being embedded after 'to', which doubled the subject. The
financial overview no longer repeats the sector sentence. Every long
text box in the deck now carries shrink autofit, verified by a
geometry checker across twelve generated scenarios. Thin margin high
COGS businesses no longer trigger a false caution verdict.

Co-Authored-By: Claude Fable 5 <noreply@anthropic.com>
</commit_message>
<xml_diff>
--- a/samples/financial_Presentation.pptx
+++ b/samples/financial_Presentation.pptx
@@ -1667,16 +1667,18 @@
         <p:spPr>
           <a:xfrm>
             <a:off x="411480" y="457200"/>
-            <a:ext cx="11365992" cy="777240"/>
-          </a:xfrm>
-          <a:prstGeom prst="rect">
-            <a:avLst/>
-          </a:prstGeom>
-          <a:noFill/>
-          <a:ln/>
-        </p:spPr>
-        <p:txBody>
-          <a:bodyPr wrap="square" rtlCol="0" anchor="t"/>
+            <a:ext cx="11365992" cy="822960"/>
+          </a:xfrm>
+          <a:prstGeom prst="rect">
+            <a:avLst/>
+          </a:prstGeom>
+          <a:noFill/>
+          <a:ln/>
+        </p:spPr>
+        <p:txBody>
+          <a:bodyPr wrap="square" rtlCol="0" anchor="t">
+            <a:normAutofit/>
+          </a:bodyPr>
           <a:lstStyle/>
           <a:p>
             <a:pPr indent="0" marL="0">
@@ -1755,7 +1757,9 @@
           <a:ln/>
         </p:spPr>
         <p:txBody>
-          <a:bodyPr wrap="square" rtlCol="0" anchor="ctr"/>
+          <a:bodyPr wrap="square" rtlCol="0" anchor="ctr">
+            <a:normAutofit/>
+          </a:bodyPr>
           <a:lstStyle/>
           <a:p>
             <a:pPr indent="0" marL="0">
@@ -1823,17 +1827,19 @@
         </p:nvSpPr>
         <p:spPr>
           <a:xfrm>
-            <a:off x="411480" y="1325880"/>
-            <a:ext cx="11365992" cy="594360"/>
-          </a:xfrm>
-          <a:prstGeom prst="rect">
-            <a:avLst/>
-          </a:prstGeom>
-          <a:noFill/>
-          <a:ln/>
-        </p:spPr>
-        <p:txBody>
-          <a:bodyPr wrap="square" rtlCol="0" anchor="t"/>
+            <a:off x="411480" y="1371600"/>
+            <a:ext cx="11365992" cy="566928"/>
+          </a:xfrm>
+          <a:prstGeom prst="rect">
+            <a:avLst/>
+          </a:prstGeom>
+          <a:noFill/>
+          <a:ln/>
+        </p:spPr>
+        <p:txBody>
+          <a:bodyPr wrap="square" rtlCol="0" anchor="t">
+            <a:normAutofit/>
+          </a:bodyPr>
           <a:lstStyle/>
           <a:p>
             <a:pPr indent="0" marL="0">
@@ -1848,7 +1854,7 @@
                 <a:ea typeface="Arial" pitchFamily="34" charset="-122"/>
                 <a:cs typeface="Arial" pitchFamily="34" charset="-120"/>
               </a:rPr>
-              <a:t>The client is evaluating the acquisition of Meridian Components Inc. to expand into the Midwest market with meaningful procurement synergies.</a:t>
+              <a:t>The client is evaluating the acquisition of Meridian Components Inc., with a focus on expand into the Midwest market with meaningful procurement synergies.</a:t>
             </a:r>
             <a:endParaRPr lang="en-US" sz="1250" dirty="0"/>
           </a:p>
@@ -1911,7 +1917,9 @@
           <a:ln/>
         </p:spPr>
         <p:txBody>
-          <a:bodyPr wrap="square" rtlCol="0" anchor="t"/>
+          <a:bodyPr wrap="square" rtlCol="0" anchor="t">
+            <a:normAutofit/>
+          </a:bodyPr>
           <a:lstStyle/>
           <a:p>
             <a:pPr indent="0" marL="0">
@@ -2071,7 +2079,9 @@
           <a:ln/>
         </p:spPr>
         <p:txBody>
-          <a:bodyPr wrap="square" rtlCol="0" anchor="t"/>
+          <a:bodyPr wrap="square" rtlCol="0" anchor="t">
+            <a:normAutofit/>
+          </a:bodyPr>
           <a:lstStyle/>
           <a:p>
             <a:pPr indent="0" marL="0">
@@ -2334,16 +2344,18 @@
         <p:spPr>
           <a:xfrm>
             <a:off x="411480" y="457200"/>
-            <a:ext cx="11365992" cy="777240"/>
-          </a:xfrm>
-          <a:prstGeom prst="rect">
-            <a:avLst/>
-          </a:prstGeom>
-          <a:noFill/>
-          <a:ln/>
-        </p:spPr>
-        <p:txBody>
-          <a:bodyPr wrap="square" rtlCol="0" anchor="t"/>
+            <a:ext cx="11365992" cy="822960"/>
+          </a:xfrm>
+          <a:prstGeom prst="rect">
+            <a:avLst/>
+          </a:prstGeom>
+          <a:noFill/>
+          <a:ln/>
+        </p:spPr>
+        <p:txBody>
+          <a:bodyPr wrap="square" rtlCol="0" anchor="t">
+            <a:normAutofit/>
+          </a:bodyPr>
           <a:lstStyle/>
           <a:p>
             <a:pPr indent="0" marL="0">
@@ -2422,7 +2434,9 @@
           <a:ln/>
         </p:spPr>
         <p:txBody>
-          <a:bodyPr wrap="square" rtlCol="0" anchor="ctr"/>
+          <a:bodyPr wrap="square" rtlCol="0" anchor="ctr">
+            <a:normAutofit/>
+          </a:bodyPr>
           <a:lstStyle/>
           <a:p>
             <a:pPr indent="0" marL="0">
@@ -2541,7 +2555,9 @@
           <a:ln/>
         </p:spPr>
         <p:txBody>
-          <a:bodyPr wrap="square" rtlCol="0" anchor="ctr"/>
+          <a:bodyPr wrap="square" rtlCol="0" anchor="ctr">
+            <a:normAutofit/>
+          </a:bodyPr>
           <a:lstStyle/>
           <a:p>
             <a:pPr indent="0" marL="0">
@@ -2594,7 +2610,9 @@
           <a:ln/>
         </p:spPr>
         <p:txBody>
-          <a:bodyPr wrap="square" rtlCol="0" anchor="t"/>
+          <a:bodyPr wrap="square" rtlCol="0" anchor="t">
+            <a:normAutofit/>
+          </a:bodyPr>
           <a:lstStyle/>
           <a:p>
             <a:pPr indent="0" marL="0">
@@ -2677,7 +2695,9 @@
           <a:ln/>
         </p:spPr>
         <p:txBody>
-          <a:bodyPr wrap="square" rtlCol="0" anchor="ctr"/>
+          <a:bodyPr wrap="square" rtlCol="0" anchor="ctr">
+            <a:normAutofit/>
+          </a:bodyPr>
           <a:lstStyle/>
           <a:p>
             <a:pPr indent="0" marL="0">
@@ -2730,7 +2750,9 @@
           <a:ln/>
         </p:spPr>
         <p:txBody>
-          <a:bodyPr wrap="square" rtlCol="0" anchor="t"/>
+          <a:bodyPr wrap="square" rtlCol="0" anchor="t">
+            <a:normAutofit/>
+          </a:bodyPr>
           <a:lstStyle/>
           <a:p>
             <a:pPr indent="0" marL="0">
@@ -2813,7 +2835,9 @@
           <a:ln/>
         </p:spPr>
         <p:txBody>
-          <a:bodyPr wrap="square" rtlCol="0" anchor="ctr"/>
+          <a:bodyPr wrap="square" rtlCol="0" anchor="ctr">
+            <a:normAutofit/>
+          </a:bodyPr>
           <a:lstStyle/>
           <a:p>
             <a:pPr indent="0" marL="0">
@@ -2866,7 +2890,9 @@
           <a:ln/>
         </p:spPr>
         <p:txBody>
-          <a:bodyPr wrap="square" rtlCol="0" anchor="t"/>
+          <a:bodyPr wrap="square" rtlCol="0" anchor="t">
+            <a:normAutofit/>
+          </a:bodyPr>
           <a:lstStyle/>
           <a:p>
             <a:pPr indent="0" marL="0">
@@ -3050,16 +3076,18 @@
         <p:spPr>
           <a:xfrm>
             <a:off x="411480" y="457200"/>
-            <a:ext cx="11365992" cy="777240"/>
-          </a:xfrm>
-          <a:prstGeom prst="rect">
-            <a:avLst/>
-          </a:prstGeom>
-          <a:noFill/>
-          <a:ln/>
-        </p:spPr>
-        <p:txBody>
-          <a:bodyPr wrap="square" rtlCol="0" anchor="t"/>
+            <a:ext cx="11365992" cy="822960"/>
+          </a:xfrm>
+          <a:prstGeom prst="rect">
+            <a:avLst/>
+          </a:prstGeom>
+          <a:noFill/>
+          <a:ln/>
+        </p:spPr>
+        <p:txBody>
+          <a:bodyPr wrap="square" rtlCol="0" anchor="t">
+            <a:normAutofit/>
+          </a:bodyPr>
           <a:lstStyle/>
           <a:p>
             <a:pPr indent="0" marL="0">
@@ -3138,7 +3166,9 @@
           <a:ln/>
         </p:spPr>
         <p:txBody>
-          <a:bodyPr wrap="square" rtlCol="0" anchor="ctr"/>
+          <a:bodyPr wrap="square" rtlCol="0" anchor="ctr">
+            <a:normAutofit/>
+          </a:bodyPr>
           <a:lstStyle/>
           <a:p>
             <a:pPr indent="0" marL="0">
@@ -3257,7 +3287,9 @@
           <a:ln/>
         </p:spPr>
         <p:txBody>
-          <a:bodyPr wrap="square" rtlCol="0" anchor="ctr"/>
+          <a:bodyPr wrap="square" rtlCol="0" anchor="ctr">
+            <a:normAutofit/>
+          </a:bodyPr>
           <a:lstStyle/>
           <a:p>
             <a:pPr indent="0" marL="0">
@@ -3310,7 +3342,9 @@
           <a:ln/>
         </p:spPr>
         <p:txBody>
-          <a:bodyPr wrap="square" rtlCol="0" anchor="t"/>
+          <a:bodyPr wrap="square" rtlCol="0" anchor="t">
+            <a:normAutofit/>
+          </a:bodyPr>
           <a:lstStyle/>
           <a:p>
             <a:pPr indent="0" marL="0">
@@ -3393,7 +3427,9 @@
           <a:ln/>
         </p:spPr>
         <p:txBody>
-          <a:bodyPr wrap="square" rtlCol="0" anchor="ctr"/>
+          <a:bodyPr wrap="square" rtlCol="0" anchor="ctr">
+            <a:normAutofit/>
+          </a:bodyPr>
           <a:lstStyle/>
           <a:p>
             <a:pPr indent="0" marL="0">
@@ -3446,7 +3482,9 @@
           <a:ln/>
         </p:spPr>
         <p:txBody>
-          <a:bodyPr wrap="square" rtlCol="0" anchor="t"/>
+          <a:bodyPr wrap="square" rtlCol="0" anchor="t">
+            <a:normAutofit/>
+          </a:bodyPr>
           <a:lstStyle/>
           <a:p>
             <a:pPr indent="0" marL="0">
@@ -3529,7 +3567,9 @@
           <a:ln/>
         </p:spPr>
         <p:txBody>
-          <a:bodyPr wrap="square" rtlCol="0" anchor="ctr"/>
+          <a:bodyPr wrap="square" rtlCol="0" anchor="ctr">
+            <a:normAutofit/>
+          </a:bodyPr>
           <a:lstStyle/>
           <a:p>
             <a:pPr indent="0" marL="0">
@@ -3582,7 +3622,9 @@
           <a:ln/>
         </p:spPr>
         <p:txBody>
-          <a:bodyPr wrap="square" rtlCol="0" anchor="t"/>
+          <a:bodyPr wrap="square" rtlCol="0" anchor="t">
+            <a:normAutofit/>
+          </a:bodyPr>
           <a:lstStyle/>
           <a:p>
             <a:pPr indent="0" marL="0">
@@ -3766,16 +3808,18 @@
         <p:spPr>
           <a:xfrm>
             <a:off x="411480" y="457200"/>
-            <a:ext cx="11365992" cy="777240"/>
-          </a:xfrm>
-          <a:prstGeom prst="rect">
-            <a:avLst/>
-          </a:prstGeom>
-          <a:noFill/>
-          <a:ln/>
-        </p:spPr>
-        <p:txBody>
-          <a:bodyPr wrap="square" rtlCol="0" anchor="t"/>
+            <a:ext cx="11365992" cy="822960"/>
+          </a:xfrm>
+          <a:prstGeom prst="rect">
+            <a:avLst/>
+          </a:prstGeom>
+          <a:noFill/>
+          <a:ln/>
+        </p:spPr>
+        <p:txBody>
+          <a:bodyPr wrap="square" rtlCol="0" anchor="t">
+            <a:normAutofit/>
+          </a:bodyPr>
           <a:lstStyle/>
           <a:p>
             <a:pPr indent="0" marL="0">
@@ -4346,7 +4390,9 @@
           <a:ln/>
         </p:spPr>
         <p:txBody>
-          <a:bodyPr wrap="square" rtlCol="0" anchor="t"/>
+          <a:bodyPr wrap="square" rtlCol="0" anchor="t">
+            <a:normAutofit/>
+          </a:bodyPr>
           <a:lstStyle/>
           <a:p>
             <a:pPr indent="0" marL="0">

</xml_diff>

<commit_message>
Output quality round: charts, formula rows, deduplicated findings
The deck summary slide now carries real data visualization: a revenue
column chart and a separate EBITDA margin line chart, single series
each, directly labeled, no gridlines. The business summary findings
box compresses to one liners instead of repeating Section 2, and the
financial table gains a revenue growth percent row. The Excel
workbook gains live growth and margin formula rows in Historicals and
a total as percent of revenue row in the model.

Co-Authored-By: Claude Fable 5 <noreply@anthropic.com>
</commit_message>
<xml_diff>
--- a/samples/financial_Presentation.pptx
+++ b/samples/financial_Presentation.pptx
@@ -109,6 +109,496 @@
     </a:lvl9pPr>
   </p:defaultTextStyle>
 </p:presentation>
+</file>
+
+<file path=ppt/charts/chart10.xml><?xml version="1.0" encoding="utf-8"?>
+<c:chartSpace xmlns:c="http://schemas.openxmlformats.org/drawingml/2006/chart" xmlns:a="http://schemas.openxmlformats.org/drawingml/2006/main" xmlns:r="http://schemas.openxmlformats.org/officeDocument/2006/relationships">
+  <c:date1904 val="0"/>
+  <c:roundedCorners val="1"/>
+  <c:chart>
+    <c:autoTitleDeleted val="1"/>
+    <c:plotArea>
+      <c:layout/>
+      <c:lineChart>
+        <c:varyColors val="0"/>
+        <c:ser>
+          <c:idx val="0"/>
+          <c:order val="0"/>
+          <c:tx>
+            <c:strRef>
+              <c:f>Sheet1!$B$1</c:f>
+              <c:strCache>
+                <c:ptCount val="1"/>
+                <c:pt idx="0">
+                  <c:v>EBITDA margin</c:v>
+                </c:pt>
+              </c:strCache>
+            </c:strRef>
+          </c:tx>
+          <c:spPr>
+            <a:solidFill>
+              <a:srgbClr val="00A0B0"/>
+            </a:solidFill>
+            <a:ln w="25400" cap="flat">
+              <a:solidFill>
+                <a:srgbClr val="00A0B0"/>
+              </a:solidFill>
+              <a:prstDash val="solid"/>
+              <a:round/>
+            </a:ln>
+            <a:effectLst/>
+          </c:spPr>
+          <c:invertIfNegative val="0"/>
+          <c:dLbls>
+            <c:numFmt formatCode="#,##0" sourceLinked="0"/>
+            <c:txPr>
+              <a:bodyPr/>
+              <a:lstStyle/>
+              <a:p>
+                <a:pPr>
+                  <a:defRPr b="0" i="0" strike="noStrike" sz="900" u="none">
+                    <a:solidFill>
+                      <a:srgbClr val="404850"/>
+                    </a:solidFill>
+                    <a:latin typeface="Arial"/>
+                  </a:defRPr>
+                </a:pPr>
+              </a:p>
+            </c:txPr>
+            <c:dLblPos val="t"/>
+            <c:showLegendKey val="0"/>
+            <c:showVal val="1"/>
+            <c:showCatName val="0"/>
+            <c:showSerName val="0"/>
+            <c:showPercent val="0"/>
+            <c:showBubbleSize val="0"/>
+            <c:showLeaderLines val="0"/>
+          </c:dLbls>
+          <c:marker>
+            <c:symbol val="circle"/>
+            <c:size val="6"/>
+            <c:spPr>
+              <a:solidFill>
+                <a:srgbClr val="00A0B0"/>
+              </a:solidFill>
+              <a:ln w="9525" cap="flat">
+                <a:solidFill>
+                  <a:srgbClr val="00A0B0"/>
+                </a:solidFill>
+                <a:prstDash val="solid"/>
+                <a:round/>
+              </a:ln>
+              <a:effectLst/>
+            </c:spPr>
+          </c:marker>
+          <c:cat>
+            <c:multiLvlStrRef>
+              <c:f>Sheet1!$A$2:$A$5</c:f>
+              <c:multiLvlStrCache>
+                <c:ptCount val="4"/>
+                <c:lvl>
+                  <c:pt idx="0">
+                    <c:v>FY21A</c:v>
+                  </c:pt>
+                  <c:pt idx="1">
+                    <c:v>FY22A</c:v>
+                  </c:pt>
+                  <c:pt idx="2">
+                    <c:v>FY23A</c:v>
+                  </c:pt>
+                  <c:pt idx="3">
+                    <c:v>FY24A</c:v>
+                  </c:pt>
+                </c:lvl>
+              </c:multiLvlStrCache>
+            </c:multiLvlStrRef>
+          </c:cat>
+          <c:val>
+            <c:numRef>
+              <c:f>Sheet1!$B$2:$B$5</c:f>
+              <c:numCache>
+                <c:formatCode>General</c:formatCode>
+                <c:ptCount val="4"/>
+                <c:pt idx="0">
+                  <c:v>15</c:v>
+                </c:pt>
+                <c:pt idx="1">
+                  <c:v>16.1</c:v>
+                </c:pt>
+                <c:pt idx="2">
+                  <c:v>17.3</c:v>
+                </c:pt>
+                <c:pt idx="3">
+                  <c:v>18.7</c:v>
+                </c:pt>
+              </c:numCache>
+            </c:numRef>
+          </c:val>
+          <c:smooth val="0"/>
+        </c:ser>
+        <c:dLbls>
+          <c:numFmt formatCode="#,##0" sourceLinked="0"/>
+          <c:txPr>
+            <a:bodyPr/>
+            <a:lstStyle/>
+            <a:p>
+              <a:pPr>
+                <a:defRPr b="0" i="0" strike="noStrike" sz="900" u="none">
+                  <a:solidFill>
+                    <a:srgbClr val="404850"/>
+                  </a:solidFill>
+                  <a:latin typeface="Arial"/>
+                </a:defRPr>
+              </a:pPr>
+            </a:p>
+          </c:txPr>
+          <c:dLblPos val="t"/>
+          <c:showLegendKey val="0"/>
+          <c:showVal val="1"/>
+          <c:showCatName val="0"/>
+          <c:showSerName val="0"/>
+          <c:showPercent val="0"/>
+          <c:showBubbleSize val="0"/>
+          <c:showLeaderLines val="0"/>
+        </c:dLbls>
+        <c:marker val="1"/>
+        <c:axId val="2094734554"/>
+        <c:axId val="2094734552"/>
+        <c:axId val="2094734556"/>
+      </c:lineChart>
+      <c:catAx>
+        <c:axId val="2094734554"/>
+        <c:scaling>
+          <c:orientation val="minMax"/>
+        </c:scaling>
+        <c:delete val="0"/>
+        <c:axPos val="b"/>
+        <c:numFmt formatCode="General" sourceLinked="1"/>
+        <c:majorTickMark val="out"/>
+        <c:minorTickMark val="none"/>
+        <c:tickLblPos val="low"/>
+        <c:spPr>
+          <a:ln w="12700" cap="flat">
+            <a:noFill/>
+            <a:prstDash val="solid"/>
+            <a:round/>
+          </a:ln>
+        </c:spPr>
+        <c:txPr>
+          <a:bodyPr/>
+          <a:lstStyle/>
+          <a:p>
+            <a:pPr>
+              <a:defRPr sz="1000" b="0" i="0" u="none" strike="noStrike">
+                <a:solidFill>
+                  <a:srgbClr val="63666A"/>
+                </a:solidFill>
+                <a:latin typeface="Arial"/>
+              </a:defRPr>
+            </a:pPr>
+            <a:endParaRPr lang="en-US"/>
+          </a:p>
+        </c:txPr>
+        <c:crossAx val="2094734552"/>
+        <c:crosses val="autoZero"/>
+        <c:auto val="1"/>
+        <c:lblAlgn val="ctr"/>
+        <c:noMultiLvlLbl val="1"/>
+      </c:catAx>
+      <c:valAx>
+        <c:axId val="2094734552"/>
+        <c:scaling>
+          <c:orientation val="minMax"/>
+        </c:scaling>
+        <c:delete val="1"/>
+        <c:axPos val="l"/>
+        <c:numFmt formatCode="General" sourceLinked="0"/>
+        <c:majorTickMark val="out"/>
+        <c:minorTickMark val="none"/>
+        <c:tickLblPos val="nextTo"/>
+        <c:spPr>
+          <a:ln w="12700" cap="flat">
+            <a:solidFill>
+              <a:srgbClr val="888888"/>
+            </a:solidFill>
+            <a:prstDash val="solid"/>
+            <a:round/>
+          </a:ln>
+        </c:spPr>
+        <c:txPr>
+          <a:bodyPr/>
+          <a:lstStyle/>
+          <a:p>
+            <a:pPr>
+              <a:defRPr sz="1200" b="0" i="0" u="none" strike="noStrike">
+                <a:solidFill>
+                  <a:srgbClr val="000000"/>
+                </a:solidFill>
+                <a:latin typeface="Arial"/>
+              </a:defRPr>
+            </a:pPr>
+            <a:endParaRPr lang="en-US"/>
+          </a:p>
+        </c:txPr>
+        <c:crossAx val="2094734554"/>
+        <c:crosses val="autoZero"/>
+        <c:crossBetween val="between"/>
+      </c:valAx>
+      <c:spPr>
+        <a:noFill/>
+        <a:ln>
+          <a:noFill/>
+        </a:ln>
+        <a:effectLst/>
+      </c:spPr>
+    </c:plotArea>
+    <c:plotVisOnly val="1"/>
+    <c:dispBlanksAs val="span"/>
+  </c:chart>
+  <c:spPr>
+    <a:noFill/>
+    <a:ln>
+      <a:noFill/>
+    </a:ln>
+    <a:effectLst/>
+  </c:spPr>
+  <c:externalData r:id="rId1">
+    <c:autoUpdate val="0"/>
+  </c:externalData>
+</c:chartSpace>
+</file>
+
+<file path=ppt/charts/chart9.xml><?xml version="1.0" encoding="utf-8"?>
+<c:chartSpace xmlns:c="http://schemas.openxmlformats.org/drawingml/2006/chart" xmlns:a="http://schemas.openxmlformats.org/drawingml/2006/main" xmlns:r="http://schemas.openxmlformats.org/officeDocument/2006/relationships">
+  <c:date1904 val="0"/>
+  <c:roundedCorners val="1"/>
+  <c:chart>
+    <c:autoTitleDeleted val="1"/>
+    <c:plotArea>
+      <c:layout/>
+      <c:barChart>
+        <c:barDir val="col"/>
+        <c:grouping val="clustered"/>
+        <c:varyColors val="0"/>
+        <c:ser>
+          <c:idx val="0"/>
+          <c:order val="0"/>
+          <c:tx>
+            <c:strRef>
+              <c:f>Sheet1!$B$1</c:f>
+              <c:strCache>
+                <c:ptCount val="1"/>
+                <c:pt idx="0">
+                  <c:v>Revenue</c:v>
+                </c:pt>
+              </c:strCache>
+            </c:strRef>
+          </c:tx>
+          <c:spPr>
+            <a:solidFill>
+              <a:srgbClr val="1F4CFF"/>
+            </a:solidFill>
+            <a:effectLst/>
+          </c:spPr>
+          <c:invertIfNegative val="0"/>
+          <c:dLbls>
+            <c:numFmt formatCode="#,##0" sourceLinked="0"/>
+            <c:txPr>
+              <a:bodyPr/>
+              <a:lstStyle/>
+              <a:p>
+                <a:pPr>
+                  <a:defRPr b="0" i="0" strike="noStrike" sz="900" u="none">
+                    <a:solidFill>
+                      <a:srgbClr val="404850"/>
+                    </a:solidFill>
+                    <a:latin typeface="Arial"/>
+                  </a:defRPr>
+                </a:pPr>
+              </a:p>
+            </c:txPr>
+            <c:showLegendKey val="0"/>
+            <c:showVal val="1"/>
+            <c:showCatName val="0"/>
+            <c:showSerName val="0"/>
+            <c:showPercent val="0"/>
+            <c:showBubbleSize val="0"/>
+            <c:showLeaderLines val="0"/>
+          </c:dLbls>
+          <c:cat>
+            <c:multiLvlStrRef>
+              <c:f>Sheet1!$A$2:$A$5</c:f>
+              <c:multiLvlStrCache>
+                <c:ptCount val="4"/>
+                <c:lvl>
+                  <c:pt idx="0">
+                    <c:v>FY21A</c:v>
+                  </c:pt>
+                  <c:pt idx="1">
+                    <c:v>FY22A</c:v>
+                  </c:pt>
+                  <c:pt idx="2">
+                    <c:v>FY23A</c:v>
+                  </c:pt>
+                  <c:pt idx="3">
+                    <c:v>FY24A</c:v>
+                  </c:pt>
+                </c:lvl>
+              </c:multiLvlStrCache>
+            </c:multiLvlStrRef>
+          </c:cat>
+          <c:val>
+            <c:numRef>
+              <c:f>Sheet1!$B$2:$B$5</c:f>
+              <c:numCache>
+                <c:formatCode>General</c:formatCode>
+                <c:ptCount val="4"/>
+                <c:pt idx="0">
+                  <c:v>142</c:v>
+                </c:pt>
+                <c:pt idx="1">
+                  <c:v>154</c:v>
+                </c:pt>
+                <c:pt idx="2">
+                  <c:v>168</c:v>
+                </c:pt>
+                <c:pt idx="3">
+                  <c:v>183</c:v>
+                </c:pt>
+              </c:numCache>
+            </c:numRef>
+          </c:val>
+        </c:ser>
+        <c:dLbls>
+          <c:numFmt formatCode="#,##0" sourceLinked="0"/>
+          <c:txPr>
+            <a:bodyPr/>
+            <a:lstStyle/>
+            <a:p>
+              <a:pPr>
+                <a:defRPr b="0" i="0" strike="noStrike" sz="900" u="none">
+                  <a:solidFill>
+                    <a:srgbClr val="404850"/>
+                  </a:solidFill>
+                  <a:latin typeface="Arial"/>
+                </a:defRPr>
+              </a:pPr>
+            </a:p>
+          </c:txPr>
+          <c:showLegendKey val="0"/>
+          <c:showVal val="1"/>
+          <c:showCatName val="0"/>
+          <c:showSerName val="0"/>
+          <c:showPercent val="0"/>
+          <c:showBubbleSize val="0"/>
+          <c:showLeaderLines val="0"/>
+        </c:dLbls>
+        <c:gapWidth val="40"/>
+        <c:overlap val="0"/>
+        <c:axId val="2094734554"/>
+        <c:axId val="2094734552"/>
+        <c:axId val="2094734556"/>
+      </c:barChart>
+      <c:catAx>
+        <c:axId val="2094734554"/>
+        <c:scaling>
+          <c:orientation val="minMax"/>
+        </c:scaling>
+        <c:delete val="0"/>
+        <c:axPos val="b"/>
+        <c:numFmt formatCode="General" sourceLinked="1"/>
+        <c:majorTickMark val="out"/>
+        <c:minorTickMark val="none"/>
+        <c:tickLblPos val="low"/>
+        <c:spPr>
+          <a:ln w="12700" cap="flat">
+            <a:noFill/>
+            <a:prstDash val="solid"/>
+            <a:round/>
+          </a:ln>
+        </c:spPr>
+        <c:txPr>
+          <a:bodyPr/>
+          <a:lstStyle/>
+          <a:p>
+            <a:pPr>
+              <a:defRPr sz="1000" b="0" i="0" u="none" strike="noStrike">
+                <a:solidFill>
+                  <a:srgbClr val="63666A"/>
+                </a:solidFill>
+                <a:latin typeface="Arial"/>
+              </a:defRPr>
+            </a:pPr>
+            <a:endParaRPr lang="en-US"/>
+          </a:p>
+        </c:txPr>
+        <c:crossAx val="2094734552"/>
+        <c:crosses val="autoZero"/>
+        <c:auto val="1"/>
+        <c:lblAlgn val="ctr"/>
+        <c:noMultiLvlLbl val="1"/>
+      </c:catAx>
+      <c:valAx>
+        <c:axId val="2094734552"/>
+        <c:scaling>
+          <c:orientation val="minMax"/>
+        </c:scaling>
+        <c:delete val="1"/>
+        <c:axPos val="l"/>
+        <c:numFmt formatCode="General" sourceLinked="0"/>
+        <c:majorTickMark val="out"/>
+        <c:minorTickMark val="none"/>
+        <c:tickLblPos val="nextTo"/>
+        <c:spPr>
+          <a:ln w="12700" cap="flat">
+            <a:solidFill>
+              <a:srgbClr val="888888"/>
+            </a:solidFill>
+            <a:prstDash val="solid"/>
+            <a:round/>
+          </a:ln>
+        </c:spPr>
+        <c:txPr>
+          <a:bodyPr/>
+          <a:lstStyle/>
+          <a:p>
+            <a:pPr>
+              <a:defRPr sz="1200" b="0" i="0" u="none" strike="noStrike">
+                <a:solidFill>
+                  <a:srgbClr val="000000"/>
+                </a:solidFill>
+                <a:latin typeface="Arial"/>
+              </a:defRPr>
+            </a:pPr>
+            <a:endParaRPr lang="en-US"/>
+          </a:p>
+        </c:txPr>
+        <c:crossAx val="2094734554"/>
+        <c:crosses val="autoZero"/>
+        <c:crossBetween val="between"/>
+      </c:valAx>
+      <c:spPr>
+        <a:noFill/>
+        <a:ln>
+          <a:noFill/>
+        </a:ln>
+        <a:effectLst/>
+      </c:spPr>
+    </c:plotArea>
+    <c:plotVisOnly val="1"/>
+    <c:dispBlanksAs val="span"/>
+  </c:chart>
+  <c:spPr>
+    <a:noFill/>
+    <a:ln>
+      <a:noFill/>
+    </a:ln>
+    <a:effectLst/>
+  </c:spPr>
+  <c:externalData r:id="rId1">
+    <c:autoUpdate val="0"/>
+  </c:externalData>
+</c:chartSpace>
 </file>
 
 <file path=ppt/notesMasters/notesMaster1.xml><?xml version="1.0" encoding="utf-8"?>
@@ -1827,8 +2317,8 @@
         </p:nvSpPr>
         <p:spPr>
           <a:xfrm>
-            <a:off x="411480" y="1371600"/>
-            <a:ext cx="11365992" cy="566928"/>
+            <a:off x="411480" y="1298448"/>
+            <a:ext cx="5623560" cy="868680"/>
           </a:xfrm>
           <a:prstGeom prst="rect">
             <a:avLst/>
@@ -1846,7 +2336,7 @@
               <a:buNone/>
             </a:pPr>
             <a:r>
-              <a:rPr lang="en-US" sz="1250" dirty="0">
+              <a:rPr lang="en-US" sz="1200" dirty="0">
                 <a:solidFill>
                   <a:srgbClr val="404850"/>
                 </a:solidFill>
@@ -1856,7 +2346,7 @@
               </a:rPr>
               <a:t>The client is evaluating the acquisition of Meridian Components Inc., with a focus on expand into the Midwest market with meaningful procurement synergies.</a:t>
             </a:r>
-            <a:endParaRPr lang="en-US" sz="1250" dirty="0"/>
+            <a:endParaRPr lang="en-US" sz="1200" dirty="0"/>
           </a:p>
         </p:txBody>
       </p:sp>
@@ -1868,8 +2358,8 @@
         </p:nvSpPr>
         <p:spPr>
           <a:xfrm>
-            <a:off x="411480" y="2057400"/>
-            <a:ext cx="5577840" cy="320040"/>
+            <a:off x="411480" y="2286000"/>
+            <a:ext cx="5623560" cy="274320"/>
           </a:xfrm>
           <a:prstGeom prst="rect">
             <a:avLst/>
@@ -1885,7 +2375,7 @@
               <a:buNone/>
             </a:pPr>
             <a:r>
-              <a:rPr lang="en-US" sz="1200" b="1" spc="100" kern="0" dirty="0">
+              <a:rPr lang="en-US" sz="1100" b="1" spc="100" kern="0" dirty="0">
                 <a:solidFill>
                   <a:srgbClr val="1F4CFF"/>
                 </a:solidFill>
@@ -1893,9 +2383,9 @@
                 <a:ea typeface="Arial" pitchFamily="34" charset="-122"/>
                 <a:cs typeface="Arial" pitchFamily="34" charset="-120"/>
               </a:rPr>
-              <a:t>1. REVENUE SYNERGIES</a:t>
-            </a:r>
-            <a:endParaRPr lang="en-US" sz="1200" dirty="0"/>
+              <a:t>1. REVENUE SYNERGIES (SLIDE 2)</a:t>
+            </a:r>
+            <a:endParaRPr lang="en-US" sz="1100" dirty="0"/>
           </a:p>
         </p:txBody>
       </p:sp>
@@ -1907,8 +2397,8 @@
         </p:nvSpPr>
         <p:spPr>
           <a:xfrm>
-            <a:off x="411480" y="2423160"/>
-            <a:ext cx="5577840" cy="2194560"/>
+            <a:off x="411480" y="2578608"/>
+            <a:ext cx="5623560" cy="1325880"/>
           </a:xfrm>
           <a:prstGeom prst="rect">
             <a:avLst/>
@@ -1924,12 +2414,12 @@
           <a:p>
             <a:pPr indent="0" marL="0">
               <a:lnSpc>
-                <a:spcPts val="2600"/>
+                <a:spcPts val="2100"/>
               </a:lnSpc>
               <a:buNone/>
             </a:pPr>
             <a:r>
-              <a:rPr lang="en-US" sz="1300" dirty="0">
+              <a:rPr lang="en-US" sz="1200" dirty="0">
                 <a:solidFill>
                   <a:srgbClr val="0A1F2E"/>
                 </a:solidFill>
@@ -1939,17 +2429,17 @@
               </a:rPr>
               <a:t>1. Cross sell into the combined customer base</a:t>
             </a:r>
-            <a:endParaRPr lang="en-US" sz="1300" dirty="0"/>
+            <a:endParaRPr lang="en-US" sz="1200" dirty="0"/>
           </a:p>
           <a:p>
             <a:pPr indent="0" marL="0">
               <a:lnSpc>
-                <a:spcPts val="2600"/>
+                <a:spcPts val="2100"/>
               </a:lnSpc>
               <a:buNone/>
             </a:pPr>
             <a:r>
-              <a:rPr lang="en-US" sz="1300" dirty="0">
+              <a:rPr lang="en-US" sz="1200" dirty="0">
                 <a:solidFill>
                   <a:srgbClr val="0A1F2E"/>
                 </a:solidFill>
@@ -1959,17 +2449,17 @@
               </a:rPr>
               <a:t>2. Pricing harmonization</a:t>
             </a:r>
-            <a:endParaRPr lang="en-US" sz="1300" dirty="0"/>
+            <a:endParaRPr lang="en-US" sz="1200" dirty="0"/>
           </a:p>
           <a:p>
             <a:pPr indent="0" marL="0">
               <a:lnSpc>
-                <a:spcPts val="2600"/>
+                <a:spcPts val="2100"/>
               </a:lnSpc>
               <a:buNone/>
             </a:pPr>
             <a:r>
-              <a:rPr lang="en-US" sz="1300" dirty="0">
+              <a:rPr lang="en-US" sz="1200" dirty="0">
                 <a:solidFill>
                   <a:srgbClr val="0A1F2E"/>
                 </a:solidFill>
@@ -1979,7 +2469,7 @@
               </a:rPr>
               <a:t>3. Key account retention program</a:t>
             </a:r>
-            <a:endParaRPr lang="en-US" sz="1300" dirty="0"/>
+            <a:endParaRPr lang="en-US" sz="1200" dirty="0"/>
           </a:p>
         </p:txBody>
       </p:sp>
@@ -1991,8 +2481,8 @@
         </p:nvSpPr>
         <p:spPr>
           <a:xfrm>
-            <a:off x="411480" y="4892040"/>
-            <a:ext cx="5577840" cy="274320"/>
+            <a:off x="411480" y="4023360"/>
+            <a:ext cx="5623560" cy="274320"/>
           </a:xfrm>
           <a:prstGeom prst="rect">
             <a:avLst/>
@@ -2008,17 +2498,17 @@
               <a:buNone/>
             </a:pPr>
             <a:r>
-              <a:rPr lang="en-US" sz="1000" i="1" dirty="0">
-                <a:solidFill>
-                  <a:srgbClr val="63666A"/>
-                </a:solidFill>
-                <a:latin typeface="Arial" pitchFamily="34" charset="0"/>
-                <a:ea typeface="Arial" pitchFamily="34" charset="-122"/>
-                <a:cs typeface="Arial" pitchFamily="34" charset="-120"/>
-              </a:rPr>
-              <a:t>Expanded on slide 2</a:t>
-            </a:r>
-            <a:endParaRPr lang="en-US" sz="1000" dirty="0"/>
+              <a:rPr lang="en-US" sz="1100" b="1" spc="100" kern="0" dirty="0">
+                <a:solidFill>
+                  <a:srgbClr val="1F4CFF"/>
+                </a:solidFill>
+                <a:latin typeface="Arial" pitchFamily="34" charset="0"/>
+                <a:ea typeface="Arial" pitchFamily="34" charset="-122"/>
+                <a:cs typeface="Arial" pitchFamily="34" charset="-120"/>
+              </a:rPr>
+              <a:t>2. COST SYNERGIES (SLIDE 3)</a:t>
+            </a:r>
+            <a:endParaRPr lang="en-US" sz="1100" dirty="0"/>
           </a:p>
         </p:txBody>
       </p:sp>
@@ -2030,47 +2520,8 @@
         </p:nvSpPr>
         <p:spPr>
           <a:xfrm>
-            <a:off x="6172200" y="2057400"/>
-            <a:ext cx="5577840" cy="320040"/>
-          </a:xfrm>
-          <a:prstGeom prst="rect">
-            <a:avLst/>
-          </a:prstGeom>
-          <a:noFill/>
-          <a:ln/>
-        </p:spPr>
-        <p:txBody>
-          <a:bodyPr wrap="square" rtlCol="0" anchor="ctr"/>
-          <a:lstStyle/>
-          <a:p>
-            <a:pPr indent="0" marL="0">
-              <a:buNone/>
-            </a:pPr>
-            <a:r>
-              <a:rPr lang="en-US" sz="1200" b="1" spc="100" kern="0" dirty="0">
-                <a:solidFill>
-                  <a:srgbClr val="1F4CFF"/>
-                </a:solidFill>
-                <a:latin typeface="Arial" pitchFamily="34" charset="0"/>
-                <a:ea typeface="Arial" pitchFamily="34" charset="-122"/>
-                <a:cs typeface="Arial" pitchFamily="34" charset="-120"/>
-              </a:rPr>
-              <a:t>2. COST SYNERGIES</a:t>
-            </a:r>
-            <a:endParaRPr lang="en-US" sz="1200" dirty="0"/>
-          </a:p>
-        </p:txBody>
-      </p:sp>
-      <p:sp>
-        <p:nvSpPr>
-          <p:cNvPr id="14" name="Text 12"/>
-          <p:cNvSpPr/>
-          <p:nvPr/>
-        </p:nvSpPr>
-        <p:spPr>
-          <a:xfrm>
-            <a:off x="6172200" y="2423160"/>
-            <a:ext cx="5577840" cy="2194560"/>
+            <a:off x="411480" y="4315968"/>
+            <a:ext cx="5623560" cy="1325880"/>
           </a:xfrm>
           <a:prstGeom prst="rect">
             <a:avLst/>
@@ -2086,12 +2537,12 @@
           <a:p>
             <a:pPr indent="0" marL="0">
               <a:lnSpc>
-                <a:spcPts val="2600"/>
+                <a:spcPts val="2100"/>
               </a:lnSpc>
               <a:buNone/>
             </a:pPr>
             <a:r>
-              <a:rPr lang="en-US" sz="1300" dirty="0">
+              <a:rPr lang="en-US" sz="1200" dirty="0">
                 <a:solidFill>
                   <a:srgbClr val="0A1F2E"/>
                 </a:solidFill>
@@ -2101,17 +2552,17 @@
               </a:rPr>
               <a:t>4. Procurement scale and vendor consolidation</a:t>
             </a:r>
-            <a:endParaRPr lang="en-US" sz="1300" dirty="0"/>
+            <a:endParaRPr lang="en-US" sz="1200" dirty="0"/>
           </a:p>
           <a:p>
             <a:pPr indent="0" marL="0">
               <a:lnSpc>
-                <a:spcPts val="2600"/>
+                <a:spcPts val="2100"/>
               </a:lnSpc>
               <a:buNone/>
             </a:pPr>
             <a:r>
-              <a:rPr lang="en-US" sz="1300" dirty="0">
+              <a:rPr lang="en-US" sz="1200" dirty="0">
                 <a:solidFill>
                   <a:srgbClr val="0A1F2E"/>
                 </a:solidFill>
@@ -2121,17 +2572,17 @@
               </a:rPr>
               <a:t>5. Margin improvement to peer levels</a:t>
             </a:r>
-            <a:endParaRPr lang="en-US" sz="1300" dirty="0"/>
+            <a:endParaRPr lang="en-US" sz="1200" dirty="0"/>
           </a:p>
           <a:p>
             <a:pPr indent="0" marL="0">
               <a:lnSpc>
-                <a:spcPts val="2600"/>
+                <a:spcPts val="2100"/>
               </a:lnSpc>
               <a:buNone/>
             </a:pPr>
             <a:r>
-              <a:rPr lang="en-US" sz="1300" dirty="0">
+              <a:rPr lang="en-US" sz="1200" dirty="0">
                 <a:solidFill>
                   <a:srgbClr val="0A1F2E"/>
                 </a:solidFill>
@@ -2141,20 +2592,20 @@
               </a:rPr>
               <a:t>6. Overlapping G&amp;A rationalization</a:t>
             </a:r>
-            <a:endParaRPr lang="en-US" sz="1300" dirty="0"/>
-          </a:p>
-        </p:txBody>
-      </p:sp>
-      <p:sp>
-        <p:nvSpPr>
-          <p:cNvPr id="15" name="Text 13"/>
-          <p:cNvSpPr/>
-          <p:nvPr/>
-        </p:nvSpPr>
-        <p:spPr>
-          <a:xfrm>
-            <a:off x="6172200" y="4892040"/>
-            <a:ext cx="5577840" cy="274320"/>
+            <a:endParaRPr lang="en-US" sz="1200" dirty="0"/>
+          </a:p>
+        </p:txBody>
+      </p:sp>
+      <p:sp>
+        <p:nvSpPr>
+          <p:cNvPr id="14" name="Text 12"/>
+          <p:cNvSpPr/>
+          <p:nvPr/>
+        </p:nvSpPr>
+        <p:spPr>
+          <a:xfrm>
+            <a:off x="6263640" y="1298448"/>
+            <a:ext cx="5513832" cy="237744"/>
           </a:xfrm>
           <a:prstGeom prst="rect">
             <a:avLst/>
@@ -2170,7 +2621,7 @@
               <a:buNone/>
             </a:pPr>
             <a:r>
-              <a:rPr lang="en-US" sz="1000" i="1" dirty="0">
+              <a:rPr lang="en-US" sz="1000" b="1" spc="100" kern="0" dirty="0">
                 <a:solidFill>
                   <a:srgbClr val="63666A"/>
                 </a:solidFill>
@@ -2178,12 +2629,83 @@
                 <a:ea typeface="Arial" pitchFamily="34" charset="-122"/>
                 <a:cs typeface="Arial" pitchFamily="34" charset="-120"/>
               </a:rPr>
-              <a:t>Expanded on slide 3</a:t>
+              <a:t>REVENUE, $M</a:t>
             </a:r>
             <a:endParaRPr lang="en-US" sz="1000" dirty="0"/>
           </a:p>
         </p:txBody>
       </p:sp>
+      <p:graphicFrame>
+        <p:nvGraphicFramePr>
+          <p:cNvPr id="15" name="Chart 0" descr=""/>
+          <p:cNvGraphicFramePr/>
+          <p:nvPr/>
+        </p:nvGraphicFramePr>
+        <p:xfrm>
+          <a:off x="6263640" y="1554480"/>
+          <a:ext cx="5513832" cy="1965960"/>
+        </p:xfrm>
+        <a:graphic xmlns:a="http://schemas.openxmlformats.org/drawingml/2006/main">
+          <a:graphicData uri="http://schemas.openxmlformats.org/drawingml/2006/chart">
+            <c:chart xmlns:c="http://schemas.openxmlformats.org/drawingml/2006/chart" r:id="rId1"/>
+          </a:graphicData>
+        </a:graphic>
+      </p:graphicFrame>
+      <p:sp>
+        <p:nvSpPr>
+          <p:cNvPr id="16" name="Text 13"/>
+          <p:cNvSpPr/>
+          <p:nvPr/>
+        </p:nvSpPr>
+        <p:spPr>
+          <a:xfrm>
+            <a:off x="6263640" y="3675888"/>
+            <a:ext cx="5513832" cy="237744"/>
+          </a:xfrm>
+          <a:prstGeom prst="rect">
+            <a:avLst/>
+          </a:prstGeom>
+          <a:noFill/>
+          <a:ln/>
+        </p:spPr>
+        <p:txBody>
+          <a:bodyPr wrap="square" rtlCol="0" anchor="ctr"/>
+          <a:lstStyle/>
+          <a:p>
+            <a:pPr indent="0" marL="0">
+              <a:buNone/>
+            </a:pPr>
+            <a:r>
+              <a:rPr lang="en-US" sz="1000" b="1" spc="100" kern="0" dirty="0">
+                <a:solidFill>
+                  <a:srgbClr val="63666A"/>
+                </a:solidFill>
+                <a:latin typeface="Arial" pitchFamily="34" charset="0"/>
+                <a:ea typeface="Arial" pitchFamily="34" charset="-122"/>
+                <a:cs typeface="Arial" pitchFamily="34" charset="-120"/>
+              </a:rPr>
+              <a:t>EBITDA MARGIN, %</a:t>
+            </a:r>
+            <a:endParaRPr lang="en-US" sz="1000" dirty="0"/>
+          </a:p>
+        </p:txBody>
+      </p:sp>
+      <p:graphicFrame>
+        <p:nvGraphicFramePr>
+          <p:cNvPr id="17" name="Chart 1" descr=""/>
+          <p:cNvGraphicFramePr/>
+          <p:nvPr/>
+        </p:nvGraphicFramePr>
+        <p:xfrm>
+          <a:off x="6263640" y="3931920"/>
+          <a:ext cx="5513832" cy="1783080"/>
+        </p:xfrm>
+        <a:graphic xmlns:a="http://schemas.openxmlformats.org/drawingml/2006/main">
+          <a:graphicData uri="http://schemas.openxmlformats.org/drawingml/2006/chart">
+            <c:chart xmlns:c="http://schemas.openxmlformats.org/drawingml/2006/chart" r:id="rId2"/>
+          </a:graphicData>
+        </a:graphic>
+      </p:graphicFrame>
       <p:sp>
         <p:nvSpPr>
           <p:cNvPr id="25" name="Slide Number Placeholder 0"/>

</xml_diff>

<commit_message>
User reported round: real slide fitting, styled linked model, profiles
PowerPoint text no longer relies on autofit, which PowerPoint ignores
until a box is edited: font sizes are precomputed to fit each box and
the geometry checker now runs strict. The Excel model is rebuilt on a
style capable library as four linked sheets: Inputs with yellow
editable cells including EV to EBITDA and revenue multiples, Model
with historicals plus a five year projection, Synergies scenarios,
and Valuation showing value creation from synergy capture, every
number a live formula. Company lookup now pulls key products and best
effort recent news; a manual profile section covers private company
people, products, and news. Manual entry labels each row in millions.

Co-Authored-By: Claude Fable 5 <noreply@anthropic.com>
</commit_message>
<xml_diff>
--- a/samples/financial_Presentation.pptx
+++ b/samples/financial_Presentation.pptx
@@ -2414,7 +2414,7 @@
           <a:p>
             <a:pPr indent="0" marL="0">
               <a:lnSpc>
-                <a:spcPts val="2100"/>
+                <a:spcPts val="2040"/>
               </a:lnSpc>
               <a:buNone/>
             </a:pPr>
@@ -2434,7 +2434,7 @@
           <a:p>
             <a:pPr indent="0" marL="0">
               <a:lnSpc>
-                <a:spcPts val="2100"/>
+                <a:spcPts val="2040"/>
               </a:lnSpc>
               <a:buNone/>
             </a:pPr>
@@ -2454,7 +2454,7 @@
           <a:p>
             <a:pPr indent="0" marL="0">
               <a:lnSpc>
-                <a:spcPts val="2100"/>
+                <a:spcPts val="2040"/>
               </a:lnSpc>
               <a:buNone/>
             </a:pPr>
@@ -2537,7 +2537,7 @@
           <a:p>
             <a:pPr indent="0" marL="0">
               <a:lnSpc>
-                <a:spcPts val="2100"/>
+                <a:spcPts val="2040"/>
               </a:lnSpc>
               <a:buNone/>
             </a:pPr>
@@ -2557,7 +2557,7 @@
           <a:p>
             <a:pPr indent="0" marL="0">
               <a:lnSpc>
-                <a:spcPts val="2100"/>
+                <a:spcPts val="2040"/>
               </a:lnSpc>
               <a:buNone/>
             </a:pPr>
@@ -2577,7 +2577,7 @@
           <a:p>
             <a:pPr indent="0" marL="0">
               <a:lnSpc>
-                <a:spcPts val="2100"/>
+                <a:spcPts val="2040"/>
               </a:lnSpc>
               <a:buNone/>
             </a:pPr>
@@ -4919,7 +4919,7 @@
           <a:p>
             <a:pPr indent="0" marL="0">
               <a:lnSpc>
-                <a:spcPts val="2000"/>
+                <a:spcPts val="1980"/>
               </a:lnSpc>
               <a:buNone/>
             </a:pPr>
@@ -4939,7 +4939,7 @@
           <a:p>
             <a:pPr indent="0" marL="0">
               <a:lnSpc>
-                <a:spcPts val="2000"/>
+                <a:spcPts val="1980"/>
               </a:lnSpc>
               <a:buNone/>
             </a:pPr>
@@ -4959,7 +4959,7 @@
           <a:p>
             <a:pPr indent="0" marL="0">
               <a:lnSpc>
-                <a:spcPts val="2000"/>
+                <a:spcPts val="1980"/>
               </a:lnSpc>
               <a:buNone/>
             </a:pPr>
@@ -4979,7 +4979,7 @@
           <a:p>
             <a:pPr indent="0" marL="0">
               <a:lnSpc>
-                <a:spcPts val="2000"/>
+                <a:spcPts val="1980"/>
               </a:lnSpc>
               <a:buNone/>
             </a:pPr>
@@ -4999,7 +4999,7 @@
           <a:p>
             <a:pPr indent="0" marL="0">
               <a:lnSpc>
-                <a:spcPts val="2000"/>
+                <a:spcPts val="1980"/>
               </a:lnSpc>
               <a:buNone/>
             </a:pPr>
@@ -5019,7 +5019,7 @@
           <a:p>
             <a:pPr indent="0" marL="0">
               <a:lnSpc>
-                <a:spcPts val="2000"/>
+                <a:spcPts val="1980"/>
               </a:lnSpc>
               <a:buNone/>
             </a:pPr>

</xml_diff>

<commit_message>
Fix slides rendering on a 10 inch canvas and Word pages as A4
The deck laid every element out on a 13.333 by 7.5 inch grid but
declared LAYOUT_16x9, which pptxgenjs defines as 10 by 5.625 inches.
The right quarter of every slide and everything below 5.6 inches,
including the takeaway bar, source line, and page number, therefore
hung off the page. The canvas is now declared explicitly. Word
documents were inheriting the library default of A4 and are now
US Letter.

Both defects came from trusting a library default and from checkers
that hardcoded the same assumption as the generator. The geometry
checker now reads the slide size out of presentation.xml, and the
adversarial suite asserts both the slide canvas and the page size.

Co-Authored-By: Claude Fable 5 <noreply@anthropic.com>
</commit_message>
<xml_diff>
--- a/samples/financial_Presentation.pptx
+++ b/samples/financial_Presentation.pptx
@@ -14,8 +14,8 @@
   <p:notesMasterIdLst>
     <p:notesMasterId r:id="rId7"/>
   </p:notesMasterIdLst>
-  <p:sldSz cx="9144000" cy="5143500"/>
-  <p:notesSz cx="5143500" cy="9144000"/>
+  <p:sldSz cx="12191695" cy="6858000"/>
+  <p:notesSz cx="6858000" cy="12191695"/>
   <p:defaultTextStyle>
     <a:lvl1pPr marL="0" algn="l" defTabSz="914400" rtl="0" eaLnBrk="1" latinLnBrk="0" hangingPunct="1">
       <a:defRPr sz="1800" kern="1200">
@@ -2157,7 +2157,7 @@
         <p:spPr>
           <a:xfrm>
             <a:off x="411480" y="457200"/>
-            <a:ext cx="11365992" cy="822960"/>
+            <a:ext cx="11368735" cy="822960"/>
           </a:xfrm>
           <a:prstGeom prst="rect">
             <a:avLst/>
@@ -2198,7 +2198,7 @@
         <p:spPr>
           <a:xfrm>
             <a:off x="411480" y="5870448"/>
-            <a:ext cx="11365992" cy="475488"/>
+            <a:ext cx="11368735" cy="475488"/>
           </a:xfrm>
           <a:prstGeom prst="rect">
             <a:avLst/>
@@ -2238,7 +2238,7 @@
         <p:spPr>
           <a:xfrm>
             <a:off x="576072" y="5870448"/>
-            <a:ext cx="11091672" cy="475488"/>
+            <a:ext cx="11094415" cy="475488"/>
           </a:xfrm>
           <a:prstGeom prst="rect">
             <a:avLst/>
@@ -2605,7 +2605,7 @@
         <p:spPr>
           <a:xfrm>
             <a:off x="6263640" y="1298448"/>
-            <a:ext cx="5513832" cy="237744"/>
+            <a:ext cx="5516575" cy="237744"/>
           </a:xfrm>
           <a:prstGeom prst="rect">
             <a:avLst/>
@@ -2643,7 +2643,7 @@
         </p:nvGraphicFramePr>
         <p:xfrm>
           <a:off x="6263640" y="1554480"/>
-          <a:ext cx="5513832" cy="1965960"/>
+          <a:ext cx="5516575" cy="1965960"/>
         </p:xfrm>
         <a:graphic xmlns:a="http://schemas.openxmlformats.org/drawingml/2006/main">
           <a:graphicData uri="http://schemas.openxmlformats.org/drawingml/2006/chart">
@@ -2660,7 +2660,7 @@
         <p:spPr>
           <a:xfrm>
             <a:off x="6263640" y="3675888"/>
-            <a:ext cx="5513832" cy="237744"/>
+            <a:ext cx="5516575" cy="237744"/>
           </a:xfrm>
           <a:prstGeom prst="rect">
             <a:avLst/>
@@ -2698,7 +2698,7 @@
         </p:nvGraphicFramePr>
         <p:xfrm>
           <a:off x="6263640" y="3931920"/>
-          <a:ext cx="5513832" cy="1783080"/>
+          <a:ext cx="5516575" cy="1783080"/>
         </p:xfrm>
         <a:graphic xmlns:a="http://schemas.openxmlformats.org/drawingml/2006/main">
           <a:graphicData uri="http://schemas.openxmlformats.org/drawingml/2006/chart">
@@ -2866,7 +2866,7 @@
         <p:spPr>
           <a:xfrm>
             <a:off x="411480" y="457200"/>
-            <a:ext cx="11365992" cy="822960"/>
+            <a:ext cx="11368735" cy="822960"/>
           </a:xfrm>
           <a:prstGeom prst="rect">
             <a:avLst/>
@@ -2907,7 +2907,7 @@
         <p:spPr>
           <a:xfrm>
             <a:off x="411480" y="5870448"/>
-            <a:ext cx="11365992" cy="475488"/>
+            <a:ext cx="11368735" cy="475488"/>
           </a:xfrm>
           <a:prstGeom prst="rect">
             <a:avLst/>
@@ -2947,7 +2947,7 @@
         <p:spPr>
           <a:xfrm>
             <a:off x="576072" y="5870448"/>
-            <a:ext cx="11091672" cy="475488"/>
+            <a:ext cx="11094415" cy="475488"/>
           </a:xfrm>
           <a:prstGeom prst="rect">
             <a:avLst/>
@@ -3598,7 +3598,7 @@
         <p:spPr>
           <a:xfrm>
             <a:off x="411480" y="457200"/>
-            <a:ext cx="11365992" cy="822960"/>
+            <a:ext cx="11368735" cy="822960"/>
           </a:xfrm>
           <a:prstGeom prst="rect">
             <a:avLst/>
@@ -3639,7 +3639,7 @@
         <p:spPr>
           <a:xfrm>
             <a:off x="411480" y="5870448"/>
-            <a:ext cx="11365992" cy="475488"/>
+            <a:ext cx="11368735" cy="475488"/>
           </a:xfrm>
           <a:prstGeom prst="rect">
             <a:avLst/>
@@ -3679,7 +3679,7 @@
         <p:spPr>
           <a:xfrm>
             <a:off x="576072" y="5870448"/>
-            <a:ext cx="11091672" cy="475488"/>
+            <a:ext cx="11094415" cy="475488"/>
           </a:xfrm>
           <a:prstGeom prst="rect">
             <a:avLst/>
@@ -4330,7 +4330,7 @@
         <p:spPr>
           <a:xfrm>
             <a:off x="411480" y="457200"/>
-            <a:ext cx="11365992" cy="822960"/>
+            <a:ext cx="11368735" cy="822960"/>
           </a:xfrm>
           <a:prstGeom prst="rect">
             <a:avLst/>

</xml_diff>

<commit_message>
Diagnosis deck: the narrative arc, driven by live filings
When live filing data is present the deck becomes the operating review
arc rather than the three slide loop: cover carrying the question,
executive summary of the numbered findings, situation with the three
headline figures, complication, the quarterly picture charted from
eight reported quarters, recommendation, risks and triggers in two
columns, and a closing slide naming the one metric to watch. Kickers,
titles, and actions follow the practice lens, and the whole deck takes
the company's own colors.

Also fixes a real geometry defect the checker had been blind to: the
page number placeholder sat 0.09in past the right edge on every deck,
because the bounds check only looked at text shapes and skipped
pictures, charts, and placeholders. The checker now inspects every
positioned element.

Co-Authored-By: Claude Fable 5 <noreply@anthropic.com>
</commit_message>
<xml_diff>
--- a/samples/financial_Presentation.pptx
+++ b/samples/financial_Presentation.pptx
@@ -1495,7 +1495,7 @@
         </p:nvSpPr>
         <p:spPr>
           <a:xfrm>
-            <a:off x="11475720" y="6601968"/>
+            <a:off x="11109960" y="6473952"/>
             <a:ext cx="800000" cy="300000"/>
           </a:xfrm>
           <a:prstGeom prst="rect">
@@ -1568,7 +1568,7 @@
         </p:nvSpPr>
         <p:spPr>
           <a:xfrm>
-            <a:off x="11475720" y="6601968"/>
+            <a:off x="11109960" y="6473952"/>
             <a:ext cx="800000" cy="300000"/>
           </a:xfrm>
           <a:prstGeom prst="rect">
@@ -2718,7 +2718,7 @@
         </p:nvSpPr>
         <p:spPr>
           <a:xfrm>
-            <a:off x="11475720" y="6601968"/>
+            <a:off x="11109960" y="6473952"/>
             <a:ext cx="800000" cy="300000"/>
           </a:xfrm>
           <a:prstGeom prst="rect">
@@ -3450,7 +3450,7 @@
         </p:nvSpPr>
         <p:spPr>
           <a:xfrm>
-            <a:off x="11475720" y="6601968"/>
+            <a:off x="11109960" y="6473952"/>
             <a:ext cx="800000" cy="300000"/>
           </a:xfrm>
           <a:prstGeom prst="rect">
@@ -4182,7 +4182,7 @@
         </p:nvSpPr>
         <p:spPr>
           <a:xfrm>
-            <a:off x="11475720" y="6601968"/>
+            <a:off x="11109960" y="6473952"/>
             <a:ext cx="800000" cy="300000"/>
           </a:xfrm>
           <a:prstGeom prst="rect">
@@ -5131,7 +5131,7 @@
         </p:nvSpPr>
         <p:spPr>
           <a:xfrm>
-            <a:off x="11475720" y="6601968"/>
+            <a:off x="11109960" y="6473952"/>
             <a:ext cx="800000" cy="300000"/>
           </a:xfrm>
           <a:prstGeom prst="rect">

</xml_diff>

<commit_message>
Task 3: the cover plus the three slide loop, and nothing after it
The brief asks for a three slide loop, a summary that signposts and
two slides that expand it in the same order. The deck was running to
five because an achievability matrix sat at the end as an appendix.
That slide is gone, leaving the cover that carries the client's logo
and colors ahead of the loop itself. The scoring behind the matrix
still ranks the opportunities that reach slides two and three.

The on screen preview built the same appendix slide, so it was removed
in step with the file rather than left to disagree with it.

Co-Authored-By: Claude Fable 5 <noreply@anthropic.com>
</commit_message>
<xml_diff>
--- a/samples/financial_Presentation.pptx
+++ b/samples/financial_Presentation.pptx
@@ -9,10 +9,9 @@
     <p:sldId id="257" r:id="rId3"/>
     <p:sldId id="258" r:id="rId4"/>
     <p:sldId id="259" r:id="rId5"/>
-    <p:sldId id="260" r:id="rId6"/>
   </p:sldIdLst>
   <p:notesMasterIdLst>
-    <p:notesMasterId r:id="rId7"/>
+    <p:notesMasterId r:id="rId6"/>
   </p:notesMasterIdLst>
   <p:sldSz cx="12191695" cy="6858000"/>
   <p:notesSz cx="6858000" cy="12191695"/>
@@ -1284,94 +1283,6 @@
             <a:fld id="{F7021451-1387-4CA6-816F-3879F97B5CBC}" type="slidenum">
               <a:rPr lang="en-US"/>
               <a:t>4</a:t>
-            </a:fld>
-            <a:endParaRPr lang="en-US"/>
-          </a:p>
-        </p:txBody>
-      </p:sp>
-    </p:spTree>
-    <p:extLst>
-      <p:ext uri="{BB962C8B-B14F-4D97-AF65-F5344CB8AC3E}">
-        <p14:creationId xmlns:p14="http://schemas.microsoft.com/office/powerpoint/2010/main" val="1024086991"/>
-      </p:ext>
-    </p:extLst>
-  </p:cSld>
-  <p:clrMapOvr>
-    <a:masterClrMapping/>
-  </p:clrMapOvr>
-</p:notes>
-</file>
-
-<file path=ppt/notesSlides/notesSlide5.xml><?xml version="1.0" encoding="utf-8"?>
-<p:notes xmlns:a="http://schemas.openxmlformats.org/drawingml/2006/main" xmlns:r="http://schemas.openxmlformats.org/officeDocument/2006/relationships" xmlns:p="http://schemas.openxmlformats.org/presentationml/2006/main">
-  <p:cSld>
-    <p:spTree>
-      <p:nvGrpSpPr>
-        <p:cNvPr id="1" name=""/>
-        <p:cNvGrpSpPr/>
-        <p:nvPr/>
-      </p:nvGrpSpPr>
-      <p:grpSpPr>
-        <a:xfrm>
-          <a:off x="0" y="0"/>
-          <a:ext cx="0" cy="0"/>
-          <a:chOff x="0" y="0"/>
-          <a:chExt cx="0" cy="0"/>
-        </a:xfrm>
-      </p:grpSpPr>
-      <p:sp>
-        <p:nvSpPr>
-          <p:cNvPr id="2" name="Slide Image Placeholder 1"/>
-          <p:cNvSpPr>
-            <a:spLocks noGrp="1" noRot="1" noChangeAspect="1"/>
-          </p:cNvSpPr>
-          <p:nvPr>
-            <p:ph type="sldImg"/>
-          </p:nvPr>
-        </p:nvSpPr>
-        <p:spPr/>
-      </p:sp>
-      <p:sp>
-        <p:nvSpPr>
-          <p:cNvPr id="3" name="Notes Placeholder 2"/>
-          <p:cNvSpPr>
-            <a:spLocks noGrp="1"/>
-          </p:cNvSpPr>
-          <p:nvPr>
-            <p:ph type="body" idx="1"/>
-          </p:nvPr>
-        </p:nvSpPr>
-        <p:spPr/>
-        <p:txBody>
-          <a:bodyPr/>
-          <a:lstStyle/>
-          <a:p>
-            <a:r>
-              <a:rPr lang="en-US" dirty="0"/>
-              <a:t/>
-            </a:r>
-            <a:endParaRPr lang="en-US" dirty="0"/>
-          </a:p>
-        </p:txBody>
-      </p:sp>
-      <p:sp>
-        <p:nvSpPr>
-          <p:cNvPr id="4" name="Slide Number Placeholder 3"/>
-          <p:cNvSpPr>
-            <a:spLocks noGrp="1"/>
-          </p:cNvSpPr>
-          <p:nvPr>
-            <p:ph type="sldNum" sz="quarter" idx="10"/>
-          </p:nvPr>
-        </p:nvSpPr>
-        <p:spPr/>
-        <p:txBody>
-          <a:bodyPr/>
-          <a:lstStyle/>
-          <a:p>
-            <a:fld id="{F7021451-1387-4CA6-816F-3879F97B5CBC}" type="slidenum">
-              <a:rPr lang="en-US"/>
-              <a:t>5</a:t>
             </a:fld>
             <a:endParaRPr lang="en-US"/>
           </a:p>
@@ -4213,955 +4124,6 @@
             <a:fld id="{F7021451-1387-4CA6-816F-3879F97B5CBC}" type="slidenum">
               <a:rPr b="0" lang="en-US"/>
               <a:t>4</a:t>
-            </a:fld>
-            <a:endParaRPr lang="en-US"/>
-          </a:p>
-        </p:txBody>
-      </p:sp>
-    </p:spTree>
-  </p:cSld>
-  <p:clrMapOvr>
-    <a:masterClrMapping/>
-  </p:clrMapOvr>
-</p:sld>
-</file>
-
-<file path=ppt/slides/slide5.xml><?xml version="1.0" encoding="utf-8"?>
-<p:sld xmlns:a="http://schemas.openxmlformats.org/drawingml/2006/main" xmlns:r="http://schemas.openxmlformats.org/officeDocument/2006/relationships" xmlns:p="http://schemas.openxmlformats.org/presentationml/2006/main">
-  <p:cSld name="Slide 5">
-    <p:spTree>
-      <p:nvGrpSpPr>
-        <p:cNvPr id="1" name=""/>
-        <p:cNvGrpSpPr/>
-        <p:nvPr/>
-      </p:nvGrpSpPr>
-      <p:grpSpPr>
-        <a:xfrm>
-          <a:off x="0" y="0"/>
-          <a:ext cx="0" cy="0"/>
-          <a:chOff x="0" y="0"/>
-          <a:chExt cx="0" cy="0"/>
-        </a:xfrm>
-      </p:grpSpPr>
-      <p:sp>
-        <p:nvSpPr>
-          <p:cNvPr id="2" name="Text 0"/>
-          <p:cNvSpPr/>
-          <p:nvPr/>
-        </p:nvSpPr>
-        <p:spPr>
-          <a:xfrm>
-            <a:off x="411480" y="164592"/>
-            <a:ext cx="8229600" cy="256032"/>
-          </a:xfrm>
-          <a:prstGeom prst="rect">
-            <a:avLst/>
-          </a:prstGeom>
-          <a:noFill/>
-          <a:ln/>
-        </p:spPr>
-        <p:txBody>
-          <a:bodyPr wrap="square" rtlCol="0" anchor="ctr"/>
-          <a:lstStyle/>
-          <a:p>
-            <a:pPr indent="0" marL="0">
-              <a:buNone/>
-            </a:pPr>
-            <a:r>
-              <a:rPr lang="en-US" sz="1000" b="1" spc="200" kern="0" dirty="0">
-                <a:solidFill>
-                  <a:srgbClr val="1F4CFF"/>
-                </a:solidFill>
-                <a:latin typeface="Arial" pitchFamily="34" charset="0"/>
-                <a:ea typeface="Arial" pitchFamily="34" charset="-122"/>
-                <a:cs typeface="Arial" pitchFamily="34" charset="-120"/>
-              </a:rPr>
-              <a:t>APPENDIX: PRIORITIZATION</a:t>
-            </a:r>
-            <a:endParaRPr lang="en-US" sz="1000" dirty="0"/>
-          </a:p>
-        </p:txBody>
-      </p:sp>
-      <p:sp>
-        <p:nvSpPr>
-          <p:cNvPr id="3" name="Text 1"/>
-          <p:cNvSpPr/>
-          <p:nvPr/>
-        </p:nvSpPr>
-        <p:spPr>
-          <a:xfrm>
-            <a:off x="9509760" y="164592"/>
-            <a:ext cx="2286000" cy="256032"/>
-          </a:xfrm>
-          <a:prstGeom prst="rect">
-            <a:avLst/>
-          </a:prstGeom>
-          <a:noFill/>
-          <a:ln/>
-        </p:spPr>
-        <p:txBody>
-          <a:bodyPr wrap="square" rtlCol="0" anchor="ctr"/>
-          <a:lstStyle/>
-          <a:p>
-            <a:pPr algn="r" indent="0" marL="0">
-              <a:buNone/>
-            </a:pPr>
-            <a:r>
-              <a:rPr lang="en-US" sz="900" dirty="0">
-                <a:solidFill>
-                  <a:srgbClr val="A6A6A6"/>
-                </a:solidFill>
-                <a:latin typeface="Arial" pitchFamily="34" charset="0"/>
-                <a:ea typeface="Arial" pitchFamily="34" charset="-122"/>
-                <a:cs typeface="Arial" pitchFamily="34" charset="-120"/>
-              </a:rPr>
-              <a:t>DRAFT | FOR DISCUSSION</a:t>
-            </a:r>
-            <a:endParaRPr lang="en-US" sz="900" dirty="0"/>
-          </a:p>
-        </p:txBody>
-      </p:sp>
-      <p:sp>
-        <p:nvSpPr>
-          <p:cNvPr id="4" name="Text 2"/>
-          <p:cNvSpPr/>
-          <p:nvPr/>
-        </p:nvSpPr>
-        <p:spPr>
-          <a:xfrm>
-            <a:off x="411480" y="457200"/>
-            <a:ext cx="11368735" cy="822960"/>
-          </a:xfrm>
-          <a:prstGeom prst="rect">
-            <a:avLst/>
-          </a:prstGeom>
-          <a:noFill/>
-          <a:ln/>
-        </p:spPr>
-        <p:txBody>
-          <a:bodyPr wrap="square" rtlCol="0" anchor="t">
-            <a:normAutofit/>
-          </a:bodyPr>
-          <a:lstStyle/>
-          <a:p>
-            <a:pPr indent="0" marL="0">
-              <a:buNone/>
-            </a:pPr>
-            <a:r>
-              <a:rPr lang="en-US" sz="1900" dirty="0">
-                <a:solidFill>
-                  <a:srgbClr val="0A1F2E"/>
-                </a:solidFill>
-                <a:latin typeface="Georgia" pitchFamily="34" charset="0"/>
-                <a:ea typeface="Georgia" pitchFamily="34" charset="-122"/>
-                <a:cs typeface="Georgia" pitchFamily="34" charset="-120"/>
-              </a:rPr>
-              <a:t>Pursue the top 3 opportunities first; hold the remainder for the roadmap</a:t>
-            </a:r>
-            <a:endParaRPr lang="en-US" sz="1900" dirty="0"/>
-          </a:p>
-        </p:txBody>
-      </p:sp>
-      <p:sp>
-        <p:nvSpPr>
-          <p:cNvPr id="5" name="Text 3"/>
-          <p:cNvSpPr/>
-          <p:nvPr/>
-        </p:nvSpPr>
-        <p:spPr>
-          <a:xfrm>
-            <a:off x="411480" y="6419088"/>
-            <a:ext cx="8229600" cy="228600"/>
-          </a:xfrm>
-          <a:prstGeom prst="rect">
-            <a:avLst/>
-          </a:prstGeom>
-          <a:noFill/>
-          <a:ln/>
-        </p:spPr>
-        <p:txBody>
-          <a:bodyPr wrap="square" rtlCol="0" anchor="ctr"/>
-          <a:lstStyle/>
-          <a:p>
-            <a:pPr indent="0" marL="0">
-              <a:buNone/>
-            </a:pPr>
-            <a:r>
-              <a:rPr lang="en-US" sz="800" dirty="0">
-                <a:solidFill>
-                  <a:srgbClr val="63666A"/>
-                </a:solidFill>
-                <a:latin typeface="Arial" pitchFamily="34" charset="0"/>
-                <a:ea typeface="Arial" pitchFamily="34" charset="-122"/>
-                <a:cs typeface="Arial" pitchFamily="34" charset="-120"/>
-              </a:rPr>
-              <a:t>Source: Illustrative sample financials; DealDesk analysis</a:t>
-            </a:r>
-            <a:endParaRPr lang="en-US" sz="800" dirty="0"/>
-          </a:p>
-        </p:txBody>
-      </p:sp>
-      <p:sp>
-        <p:nvSpPr>
-          <p:cNvPr id="6" name="Shape 4"/>
-          <p:cNvSpPr/>
-          <p:nvPr/>
-        </p:nvSpPr>
-        <p:spPr>
-          <a:xfrm>
-            <a:off x="1005840" y="1417320"/>
-            <a:ext cx="6400800" cy="4114800"/>
-          </a:xfrm>
-          <a:prstGeom prst="rect">
-            <a:avLst/>
-          </a:prstGeom>
-          <a:solidFill>
-            <a:srgbClr val="FAFBFC"/>
-          </a:solidFill>
-          <a:ln w="12700">
-            <a:solidFill>
-              <a:srgbClr val="D9D9D9"/>
-            </a:solidFill>
-            <a:prstDash val="solid"/>
-          </a:ln>
-        </p:spPr>
-      </p:sp>
-      <p:sp>
-        <p:nvSpPr>
-          <p:cNvPr id="7" name="Shape 5"/>
-          <p:cNvSpPr/>
-          <p:nvPr/>
-        </p:nvSpPr>
-        <p:spPr>
-          <a:xfrm>
-            <a:off x="4206240" y="1417320"/>
-            <a:ext cx="3200400" cy="2057400"/>
-          </a:xfrm>
-          <a:prstGeom prst="rect">
-            <a:avLst/>
-          </a:prstGeom>
-          <a:solidFill>
-            <a:srgbClr val="E8EDFF"/>
-          </a:solidFill>
-          <a:ln/>
-        </p:spPr>
-      </p:sp>
-      <p:sp>
-        <p:nvSpPr>
-          <p:cNvPr id="8" name="Shape 6"/>
-          <p:cNvSpPr/>
-          <p:nvPr/>
-        </p:nvSpPr>
-        <p:spPr>
-          <a:xfrm>
-            <a:off x="4206240" y="1417320"/>
-            <a:ext cx="0" cy="4114800"/>
-          </a:xfrm>
-          <a:prstGeom prst="line">
-            <a:avLst/>
-          </a:prstGeom>
-          <a:noFill/>
-          <a:ln w="12700">
-            <a:solidFill>
-              <a:srgbClr val="D9D9D9"/>
-            </a:solidFill>
-            <a:prstDash val="dash"/>
-          </a:ln>
-        </p:spPr>
-      </p:sp>
-      <p:sp>
-        <p:nvSpPr>
-          <p:cNvPr id="9" name="Shape 7"/>
-          <p:cNvSpPr/>
-          <p:nvPr/>
-        </p:nvSpPr>
-        <p:spPr>
-          <a:xfrm>
-            <a:off x="1005840" y="3474720"/>
-            <a:ext cx="6400800" cy="0"/>
-          </a:xfrm>
-          <a:prstGeom prst="line">
-            <a:avLst/>
-          </a:prstGeom>
-          <a:noFill/>
-          <a:ln w="12700">
-            <a:solidFill>
-              <a:srgbClr val="D9D9D9"/>
-            </a:solidFill>
-            <a:prstDash val="dash"/>
-          </a:ln>
-        </p:spPr>
-      </p:sp>
-      <p:sp>
-        <p:nvSpPr>
-          <p:cNvPr id="10" name="Text 8"/>
-          <p:cNvSpPr/>
-          <p:nvPr/>
-        </p:nvSpPr>
-        <p:spPr>
-          <a:xfrm>
-            <a:off x="4206240" y="1463040"/>
-            <a:ext cx="3108960" cy="274320"/>
-          </a:xfrm>
-          <a:prstGeom prst="rect">
-            <a:avLst/>
-          </a:prstGeom>
-          <a:noFill/>
-          <a:ln/>
-        </p:spPr>
-        <p:txBody>
-          <a:bodyPr wrap="square" rtlCol="0" anchor="ctr"/>
-          <a:lstStyle/>
-          <a:p>
-            <a:pPr algn="r" indent="0" marL="0">
-              <a:buNone/>
-            </a:pPr>
-            <a:r>
-              <a:rPr lang="en-US" sz="1000" b="1" dirty="0">
-                <a:solidFill>
-                  <a:srgbClr val="1F4CFF"/>
-                </a:solidFill>
-                <a:latin typeface="Arial" pitchFamily="34" charset="0"/>
-                <a:ea typeface="Arial" pitchFamily="34" charset="-122"/>
-                <a:cs typeface="Arial" pitchFamily="34" charset="-120"/>
-              </a:rPr>
-              <a:t>Do first</a:t>
-            </a:r>
-            <a:endParaRPr lang="en-US" sz="1000" dirty="0"/>
-          </a:p>
-        </p:txBody>
-      </p:sp>
-      <p:sp>
-        <p:nvSpPr>
-          <p:cNvPr id="11" name="Text 9"/>
-          <p:cNvSpPr/>
-          <p:nvPr/>
-        </p:nvSpPr>
-        <p:spPr>
-          <a:xfrm rot="16200000">
-            <a:off x="137160" y="3291840"/>
-            <a:ext cx="1554480" cy="365760"/>
-          </a:xfrm>
-          <a:prstGeom prst="rect">
-            <a:avLst/>
-          </a:prstGeom>
-          <a:noFill/>
-          <a:ln/>
-        </p:spPr>
-        <p:txBody>
-          <a:bodyPr wrap="square" rtlCol="0" anchor="ctr"/>
-          <a:lstStyle/>
-          <a:p>
-            <a:pPr algn="ctr" indent="0" marL="0">
-              <a:buNone/>
-            </a:pPr>
-            <a:r>
-              <a:rPr lang="en-US" sz="1100" dirty="0">
-                <a:solidFill>
-                  <a:srgbClr val="63666A"/>
-                </a:solidFill>
-                <a:latin typeface="Arial" pitchFamily="34" charset="0"/>
-                <a:ea typeface="Arial" pitchFamily="34" charset="-122"/>
-                <a:cs typeface="Arial" pitchFamily="34" charset="-120"/>
-              </a:rPr>
-              <a:t>Value impact</a:t>
-            </a:r>
-            <a:endParaRPr lang="en-US" sz="1100" dirty="0"/>
-          </a:p>
-        </p:txBody>
-      </p:sp>
-      <p:sp>
-        <p:nvSpPr>
-          <p:cNvPr id="12" name="Text 10"/>
-          <p:cNvSpPr/>
-          <p:nvPr/>
-        </p:nvSpPr>
-        <p:spPr>
-          <a:xfrm>
-            <a:off x="1005840" y="5623560"/>
-            <a:ext cx="6400800" cy="274320"/>
-          </a:xfrm>
-          <a:prstGeom prst="rect">
-            <a:avLst/>
-          </a:prstGeom>
-          <a:noFill/>
-          <a:ln/>
-        </p:spPr>
-        <p:txBody>
-          <a:bodyPr wrap="square" rtlCol="0" anchor="ctr"/>
-          <a:lstStyle/>
-          <a:p>
-            <a:pPr algn="ctr" indent="0" marL="0">
-              <a:buNone/>
-            </a:pPr>
-            <a:r>
-              <a:rPr lang="en-US" sz="1100" dirty="0">
-                <a:solidFill>
-                  <a:srgbClr val="63666A"/>
-                </a:solidFill>
-                <a:latin typeface="Arial" pitchFamily="34" charset="0"/>
-                <a:ea typeface="Arial" pitchFamily="34" charset="-122"/>
-                <a:cs typeface="Arial" pitchFamily="34" charset="-120"/>
-              </a:rPr>
-              <a:t>Ease of capture</a:t>
-            </a:r>
-            <a:endParaRPr lang="en-US" sz="1100" dirty="0"/>
-          </a:p>
-        </p:txBody>
-      </p:sp>
-      <p:sp>
-        <p:nvSpPr>
-          <p:cNvPr id="13" name="Text 11"/>
-          <p:cNvSpPr/>
-          <p:nvPr/>
-        </p:nvSpPr>
-        <p:spPr>
-          <a:xfrm>
-            <a:off x="4014216" y="2048256"/>
-            <a:ext cx="384048" cy="384048"/>
-          </a:xfrm>
-          <a:prstGeom prst="ellipse">
-            <a:avLst/>
-          </a:prstGeom>
-          <a:solidFill>
-            <a:srgbClr val="00A0B0"/>
-          </a:solidFill>
-          <a:ln/>
-        </p:spPr>
-        <p:txBody>
-          <a:bodyPr wrap="square" rtlCol="0" anchor="ctr"/>
-          <a:lstStyle/>
-          <a:p>
-            <a:pPr algn="ctr" indent="0" marL="0">
-              <a:buNone/>
-            </a:pPr>
-            <a:r>
-              <a:rPr lang="en-US" sz="1200" b="1" dirty="0">
-                <a:solidFill>
-                  <a:srgbClr val="FFFFFF"/>
-                </a:solidFill>
-                <a:latin typeface="Arial" pitchFamily="34" charset="0"/>
-                <a:ea typeface="Arial" pitchFamily="34" charset="-122"/>
-                <a:cs typeface="Arial" pitchFamily="34" charset="-120"/>
-              </a:rPr>
-              <a:t>1</a:t>
-            </a:r>
-            <a:endParaRPr lang="en-US" sz="1200" dirty="0"/>
-          </a:p>
-        </p:txBody>
-      </p:sp>
-      <p:sp>
-        <p:nvSpPr>
-          <p:cNvPr id="14" name="Text 12"/>
-          <p:cNvSpPr/>
-          <p:nvPr/>
-        </p:nvSpPr>
-        <p:spPr>
-          <a:xfrm>
-            <a:off x="5934456" y="3282696"/>
-            <a:ext cx="384048" cy="384048"/>
-          </a:xfrm>
-          <a:prstGeom prst="ellipse">
-            <a:avLst/>
-          </a:prstGeom>
-          <a:solidFill>
-            <a:srgbClr val="00A0B0"/>
-          </a:solidFill>
-          <a:ln/>
-        </p:spPr>
-        <p:txBody>
-          <a:bodyPr wrap="square" rtlCol="0" anchor="ctr"/>
-          <a:lstStyle/>
-          <a:p>
-            <a:pPr algn="ctr" indent="0" marL="0">
-              <a:buNone/>
-            </a:pPr>
-            <a:r>
-              <a:rPr lang="en-US" sz="1200" b="1" dirty="0">
-                <a:solidFill>
-                  <a:srgbClr val="FFFFFF"/>
-                </a:solidFill>
-                <a:latin typeface="Arial" pitchFamily="34" charset="0"/>
-                <a:ea typeface="Arial" pitchFamily="34" charset="-122"/>
-                <a:cs typeface="Arial" pitchFamily="34" charset="-120"/>
-              </a:rPr>
-              <a:t>2</a:t>
-            </a:r>
-            <a:endParaRPr lang="en-US" sz="1200" dirty="0"/>
-          </a:p>
-        </p:txBody>
-      </p:sp>
-      <p:sp>
-        <p:nvSpPr>
-          <p:cNvPr id="15" name="Text 13"/>
-          <p:cNvSpPr/>
-          <p:nvPr/>
-        </p:nvSpPr>
-        <p:spPr>
-          <a:xfrm>
-            <a:off x="4517136" y="2048256"/>
-            <a:ext cx="384048" cy="384048"/>
-          </a:xfrm>
-          <a:prstGeom prst="ellipse">
-            <a:avLst/>
-          </a:prstGeom>
-          <a:solidFill>
-            <a:srgbClr val="00A0B0"/>
-          </a:solidFill>
-          <a:ln/>
-        </p:spPr>
-        <p:txBody>
-          <a:bodyPr wrap="square" rtlCol="0" anchor="ctr"/>
-          <a:lstStyle/>
-          <a:p>
-            <a:pPr algn="ctr" indent="0" marL="0">
-              <a:buNone/>
-            </a:pPr>
-            <a:r>
-              <a:rPr lang="en-US" sz="1200" b="1" dirty="0">
-                <a:solidFill>
-                  <a:srgbClr val="FFFFFF"/>
-                </a:solidFill>
-                <a:latin typeface="Arial" pitchFamily="34" charset="0"/>
-                <a:ea typeface="Arial" pitchFamily="34" charset="-122"/>
-                <a:cs typeface="Arial" pitchFamily="34" charset="-120"/>
-              </a:rPr>
-              <a:t>3</a:t>
-            </a:r>
-            <a:endParaRPr lang="en-US" sz="1200" dirty="0"/>
-          </a:p>
-        </p:txBody>
-      </p:sp>
-      <p:sp>
-        <p:nvSpPr>
-          <p:cNvPr id="16" name="Text 14"/>
-          <p:cNvSpPr/>
-          <p:nvPr/>
-        </p:nvSpPr>
-        <p:spPr>
-          <a:xfrm>
-            <a:off x="5934456" y="2048256"/>
-            <a:ext cx="384048" cy="384048"/>
-          </a:xfrm>
-          <a:prstGeom prst="ellipse">
-            <a:avLst/>
-          </a:prstGeom>
-          <a:solidFill>
-            <a:srgbClr val="1F4CFF"/>
-          </a:solidFill>
-          <a:ln/>
-        </p:spPr>
-        <p:txBody>
-          <a:bodyPr wrap="square" rtlCol="0" anchor="ctr"/>
-          <a:lstStyle/>
-          <a:p>
-            <a:pPr algn="ctr" indent="0" marL="0">
-              <a:buNone/>
-            </a:pPr>
-            <a:r>
-              <a:rPr lang="en-US" sz="1200" b="1" dirty="0">
-                <a:solidFill>
-                  <a:srgbClr val="FFFFFF"/>
-                </a:solidFill>
-                <a:latin typeface="Arial" pitchFamily="34" charset="0"/>
-                <a:ea typeface="Arial" pitchFamily="34" charset="-122"/>
-                <a:cs typeface="Arial" pitchFamily="34" charset="-120"/>
-              </a:rPr>
-              <a:t>4</a:t>
-            </a:r>
-            <a:endParaRPr lang="en-US" sz="1200" dirty="0"/>
-          </a:p>
-        </p:txBody>
-      </p:sp>
-      <p:sp>
-        <p:nvSpPr>
-          <p:cNvPr id="17" name="Text 15"/>
-          <p:cNvSpPr/>
-          <p:nvPr/>
-        </p:nvSpPr>
-        <p:spPr>
-          <a:xfrm>
-            <a:off x="5020056" y="2048256"/>
-            <a:ext cx="384048" cy="384048"/>
-          </a:xfrm>
-          <a:prstGeom prst="ellipse">
-            <a:avLst/>
-          </a:prstGeom>
-          <a:solidFill>
-            <a:srgbClr val="1F4CFF"/>
-          </a:solidFill>
-          <a:ln/>
-        </p:spPr>
-        <p:txBody>
-          <a:bodyPr wrap="square" rtlCol="0" anchor="ctr"/>
-          <a:lstStyle/>
-          <a:p>
-            <a:pPr algn="ctr" indent="0" marL="0">
-              <a:buNone/>
-            </a:pPr>
-            <a:r>
-              <a:rPr lang="en-US" sz="1200" b="1" dirty="0">
-                <a:solidFill>
-                  <a:srgbClr val="FFFFFF"/>
-                </a:solidFill>
-                <a:latin typeface="Arial" pitchFamily="34" charset="0"/>
-                <a:ea typeface="Arial" pitchFamily="34" charset="-122"/>
-                <a:cs typeface="Arial" pitchFamily="34" charset="-120"/>
-              </a:rPr>
-              <a:t>5</a:t>
-            </a:r>
-            <a:endParaRPr lang="en-US" sz="1200" dirty="0"/>
-          </a:p>
-        </p:txBody>
-      </p:sp>
-      <p:sp>
-        <p:nvSpPr>
-          <p:cNvPr id="18" name="Text 16"/>
-          <p:cNvSpPr/>
-          <p:nvPr/>
-        </p:nvSpPr>
-        <p:spPr>
-          <a:xfrm>
-            <a:off x="4014216" y="3282696"/>
-            <a:ext cx="384048" cy="384048"/>
-          </a:xfrm>
-          <a:prstGeom prst="ellipse">
-            <a:avLst/>
-          </a:prstGeom>
-          <a:solidFill>
-            <a:srgbClr val="1F4CFF"/>
-          </a:solidFill>
-          <a:ln/>
-        </p:spPr>
-        <p:txBody>
-          <a:bodyPr wrap="square" rtlCol="0" anchor="ctr"/>
-          <a:lstStyle/>
-          <a:p>
-            <a:pPr algn="ctr" indent="0" marL="0">
-              <a:buNone/>
-            </a:pPr>
-            <a:r>
-              <a:rPr lang="en-US" sz="1200" b="1" dirty="0">
-                <a:solidFill>
-                  <a:srgbClr val="FFFFFF"/>
-                </a:solidFill>
-                <a:latin typeface="Arial" pitchFamily="34" charset="0"/>
-                <a:ea typeface="Arial" pitchFamily="34" charset="-122"/>
-                <a:cs typeface="Arial" pitchFamily="34" charset="-120"/>
-              </a:rPr>
-              <a:t>6</a:t>
-            </a:r>
-            <a:endParaRPr lang="en-US" sz="1200" dirty="0"/>
-          </a:p>
-        </p:txBody>
-      </p:sp>
-      <p:sp>
-        <p:nvSpPr>
-          <p:cNvPr id="19" name="Text 17"/>
-          <p:cNvSpPr/>
-          <p:nvPr/>
-        </p:nvSpPr>
-        <p:spPr>
-          <a:xfrm>
-            <a:off x="7818120" y="1417320"/>
-            <a:ext cx="3931920" cy="274320"/>
-          </a:xfrm>
-          <a:prstGeom prst="rect">
-            <a:avLst/>
-          </a:prstGeom>
-          <a:noFill/>
-          <a:ln/>
-        </p:spPr>
-        <p:txBody>
-          <a:bodyPr wrap="square" rtlCol="0" anchor="ctr"/>
-          <a:lstStyle/>
-          <a:p>
-            <a:pPr indent="0" marL="0">
-              <a:buNone/>
-            </a:pPr>
-            <a:r>
-              <a:rPr lang="en-US" sz="1100" b="1" dirty="0">
-                <a:solidFill>
-                  <a:srgbClr val="0A1F2E"/>
-                </a:solidFill>
-                <a:latin typeface="Arial" pitchFamily="34" charset="0"/>
-                <a:ea typeface="Arial" pitchFamily="34" charset="-122"/>
-                <a:cs typeface="Arial" pitchFamily="34" charset="-120"/>
-              </a:rPr>
-              <a:t>Opportunities</a:t>
-            </a:r>
-            <a:endParaRPr lang="en-US" sz="1100" dirty="0"/>
-          </a:p>
-        </p:txBody>
-      </p:sp>
-      <p:sp>
-        <p:nvSpPr>
-          <p:cNvPr id="20" name="Text 18"/>
-          <p:cNvSpPr/>
-          <p:nvPr/>
-        </p:nvSpPr>
-        <p:spPr>
-          <a:xfrm>
-            <a:off x="7818120" y="1737360"/>
-            <a:ext cx="3931920" cy="3840480"/>
-          </a:xfrm>
-          <a:prstGeom prst="rect">
-            <a:avLst/>
-          </a:prstGeom>
-          <a:noFill/>
-          <a:ln/>
-        </p:spPr>
-        <p:txBody>
-          <a:bodyPr wrap="square" rtlCol="0" anchor="t">
-            <a:normAutofit/>
-          </a:bodyPr>
-          <a:lstStyle/>
-          <a:p>
-            <a:pPr indent="0" marL="0">
-              <a:lnSpc>
-                <a:spcPts val="1980"/>
-              </a:lnSpc>
-              <a:buNone/>
-            </a:pPr>
-            <a:r>
-              <a:rPr lang="en-US" sz="1100" dirty="0">
-                <a:solidFill>
-                  <a:srgbClr val="404850"/>
-                </a:solidFill>
-                <a:latin typeface="Arial" pitchFamily="34" charset="0"/>
-                <a:ea typeface="Arial" pitchFamily="34" charset="-122"/>
-                <a:cs typeface="Arial" pitchFamily="34" charset="-120"/>
-              </a:rPr>
-              <a:t>1. Cross sell into the combined customer base</a:t>
-            </a:r>
-            <a:endParaRPr lang="en-US" sz="1100" dirty="0"/>
-          </a:p>
-          <a:p>
-            <a:pPr indent="0" marL="0">
-              <a:lnSpc>
-                <a:spcPts val="1980"/>
-              </a:lnSpc>
-              <a:buNone/>
-            </a:pPr>
-            <a:r>
-              <a:rPr lang="en-US" sz="1100" dirty="0">
-                <a:solidFill>
-                  <a:srgbClr val="404850"/>
-                </a:solidFill>
-                <a:latin typeface="Arial" pitchFamily="34" charset="0"/>
-                <a:ea typeface="Arial" pitchFamily="34" charset="-122"/>
-                <a:cs typeface="Arial" pitchFamily="34" charset="-120"/>
-              </a:rPr>
-              <a:t>2. Pricing harmonization</a:t>
-            </a:r>
-            <a:endParaRPr lang="en-US" sz="1100" dirty="0"/>
-          </a:p>
-          <a:p>
-            <a:pPr indent="0" marL="0">
-              <a:lnSpc>
-                <a:spcPts val="1980"/>
-              </a:lnSpc>
-              <a:buNone/>
-            </a:pPr>
-            <a:r>
-              <a:rPr lang="en-US" sz="1100" dirty="0">
-                <a:solidFill>
-                  <a:srgbClr val="404850"/>
-                </a:solidFill>
-                <a:latin typeface="Arial" pitchFamily="34" charset="0"/>
-                <a:ea typeface="Arial" pitchFamily="34" charset="-122"/>
-                <a:cs typeface="Arial" pitchFamily="34" charset="-120"/>
-              </a:rPr>
-              <a:t>3. Key account retention program</a:t>
-            </a:r>
-            <a:endParaRPr lang="en-US" sz="1100" dirty="0"/>
-          </a:p>
-          <a:p>
-            <a:pPr indent="0" marL="0">
-              <a:lnSpc>
-                <a:spcPts val="1980"/>
-              </a:lnSpc>
-              <a:buNone/>
-            </a:pPr>
-            <a:r>
-              <a:rPr lang="en-US" sz="1100" dirty="0">
-                <a:solidFill>
-                  <a:srgbClr val="404850"/>
-                </a:solidFill>
-                <a:latin typeface="Arial" pitchFamily="34" charset="0"/>
-                <a:ea typeface="Arial" pitchFamily="34" charset="-122"/>
-                <a:cs typeface="Arial" pitchFamily="34" charset="-120"/>
-              </a:rPr>
-              <a:t>4. Procurement scale and vendor consolidation</a:t>
-            </a:r>
-            <a:endParaRPr lang="en-US" sz="1100" dirty="0"/>
-          </a:p>
-          <a:p>
-            <a:pPr indent="0" marL="0">
-              <a:lnSpc>
-                <a:spcPts val="1980"/>
-              </a:lnSpc>
-              <a:buNone/>
-            </a:pPr>
-            <a:r>
-              <a:rPr lang="en-US" sz="1100" dirty="0">
-                <a:solidFill>
-                  <a:srgbClr val="404850"/>
-                </a:solidFill>
-                <a:latin typeface="Arial" pitchFamily="34" charset="0"/>
-                <a:ea typeface="Arial" pitchFamily="34" charset="-122"/>
-                <a:cs typeface="Arial" pitchFamily="34" charset="-120"/>
-              </a:rPr>
-              <a:t>5. Margin improvement to peer levels</a:t>
-            </a:r>
-            <a:endParaRPr lang="en-US" sz="1100" dirty="0"/>
-          </a:p>
-          <a:p>
-            <a:pPr indent="0" marL="0">
-              <a:lnSpc>
-                <a:spcPts val="1980"/>
-              </a:lnSpc>
-              <a:buNone/>
-            </a:pPr>
-            <a:r>
-              <a:rPr lang="en-US" sz="1100" dirty="0">
-                <a:solidFill>
-                  <a:srgbClr val="404850"/>
-                </a:solidFill>
-                <a:latin typeface="Arial" pitchFamily="34" charset="0"/>
-                <a:ea typeface="Arial" pitchFamily="34" charset="-122"/>
-                <a:cs typeface="Arial" pitchFamily="34" charset="-120"/>
-              </a:rPr>
-              <a:t>6. Overlapping G&amp;A rationalization</a:t>
-            </a:r>
-            <a:endParaRPr lang="en-US" sz="1100" dirty="0"/>
-          </a:p>
-        </p:txBody>
-      </p:sp>
-      <p:sp>
-        <p:nvSpPr>
-          <p:cNvPr id="21" name="Text 19"/>
-          <p:cNvSpPr/>
-          <p:nvPr/>
-        </p:nvSpPr>
-        <p:spPr>
-          <a:xfrm>
-            <a:off x="7818120" y="5212080"/>
-            <a:ext cx="3657600" cy="274320"/>
-          </a:xfrm>
-          <a:prstGeom prst="rect">
-            <a:avLst/>
-          </a:prstGeom>
-          <a:noFill/>
-          <a:ln/>
-        </p:spPr>
-        <p:txBody>
-          <a:bodyPr wrap="square" rtlCol="0" anchor="ctr"/>
-          <a:lstStyle/>
-          <a:p>
-            <a:pPr indent="0" marL="0">
-              <a:buNone/>
-            </a:pPr>
-            <a:r>
-              <a:rPr lang="en-US" sz="1000" dirty="0">
-                <a:solidFill>
-                  <a:srgbClr val="00A0B0"/>
-                </a:solidFill>
-                <a:latin typeface="Arial" pitchFamily="34" charset="0"/>
-                <a:ea typeface="Arial" pitchFamily="34" charset="-122"/>
-                <a:cs typeface="Arial" pitchFamily="34" charset="-120"/>
-              </a:rPr>
-              <a:t>● </a:t>
-            </a:r>
-            <a:pPr indent="0" marL="0">
-              <a:buNone/>
-            </a:pPr>
-            <a:r>
-              <a:rPr lang="en-US" sz="1000" dirty="0">
-                <a:solidFill>
-                  <a:srgbClr val="63666A"/>
-                </a:solidFill>
-                <a:latin typeface="Arial" pitchFamily="34" charset="0"/>
-                <a:ea typeface="Arial" pitchFamily="34" charset="-122"/>
-                <a:cs typeface="Arial" pitchFamily="34" charset="-120"/>
-              </a:rPr>
-              <a:t>Revenue synergies   </a:t>
-            </a:r>
-            <a:pPr indent="0" marL="0">
-              <a:buNone/>
-            </a:pPr>
-            <a:r>
-              <a:rPr lang="en-US" sz="1000" dirty="0">
-                <a:solidFill>
-                  <a:srgbClr val="1F4CFF"/>
-                </a:solidFill>
-                <a:latin typeface="Arial" pitchFamily="34" charset="0"/>
-                <a:ea typeface="Arial" pitchFamily="34" charset="-122"/>
-                <a:cs typeface="Arial" pitchFamily="34" charset="-120"/>
-              </a:rPr>
-              <a:t>● </a:t>
-            </a:r>
-            <a:pPr indent="0" marL="0">
-              <a:buNone/>
-            </a:pPr>
-            <a:r>
-              <a:rPr lang="en-US" sz="1000" dirty="0">
-                <a:solidFill>
-                  <a:srgbClr val="63666A"/>
-                </a:solidFill>
-                <a:latin typeface="Arial" pitchFamily="34" charset="0"/>
-                <a:ea typeface="Arial" pitchFamily="34" charset="-122"/>
-                <a:cs typeface="Arial" pitchFamily="34" charset="-120"/>
-              </a:rPr>
-              <a:t>Cost synergies</a:t>
-            </a:r>
-            <a:endParaRPr lang="en-US" sz="1000" dirty="0"/>
-          </a:p>
-        </p:txBody>
-      </p:sp>
-      <p:sp>
-        <p:nvSpPr>
-          <p:cNvPr id="25" name="Slide Number Placeholder 0"/>
-          <p:cNvSpPr>
-            <a:spLocks noGrp="1"/>
-          </p:cNvSpPr>
-          <p:nvPr>
-            <p:ph type="sldNum" sz="quarter" idx="4294967295"/>
-          </p:nvPr>
-        </p:nvSpPr>
-        <p:spPr>
-          <a:xfrm>
-            <a:off x="11109960" y="6473952"/>
-            <a:ext cx="800000" cy="300000"/>
-          </a:xfrm>
-          <a:prstGeom prst="rect">
-            <a:avLst/>
-          </a:prstGeom>
-          <a:extLst>
-            <a:ext uri="{C572A759-6A51-4108-AA02-DFA0A04FC94B}">
-              <ma14:wrappingTextBoxFlag xmlns:ma14="http://schemas.microsoft.com/office/mac/drawingml/2011/main" val="0"/>
-            </a:ext>
-          </a:extLst>
-        </p:spPr>
-        <p:txBody>
-          <a:bodyPr/>
-          <a:lstStyle>
-            <a:lvl1pPr>
-              <a:defRPr sz="900">
-                <a:solidFill>
-                  <a:srgbClr val="63666A"/>
-                </a:solidFill>
-                <a:latin typeface="Arial"/>
-                <a:ea typeface="Arial"/>
-                <a:cs typeface="Arial"/>
-              </a:defRPr>
-            </a:lvl1pPr>
-          </a:lstStyle>
-          <a:p>
-            <a:pPr algn="l"/>
-            <a:fld id="{F7021451-1387-4CA6-816F-3879F97B5CBC}" type="slidenum">
-              <a:rPr b="0" lang="en-US"/>
-              <a:t>5</a:t>
             </a:fld>
             <a:endParaRPr lang="en-US"/>
           </a:p>

</xml_diff>